<commit_message>
Fix feature-importance labels on Spark 4; show actual Spark version
Spark 4 orders the VectorAssembler attribute groups differently (binary
before numeric), so names were attached to the wrong importances.
Sort all attributes by vector index and assert the alignment. Report and
deck now take the Spark version from the run instead of hard-coding 3.5.

Co-Authored-By: Claude Opus 5.5 <noreply@anthropic.com>
Claude-Session: https://claude.ai/code/session_013cmZjtFTpWtFMxYtK982h3
</commit_message>
<xml_diff>
--- a/bdmla-flight-delay/presentation/BDMLA_CW1_Flight_Delay_Presentation.pptx
+++ b/bdmla-flight-delay/presentation/BDMLA_CW1_Flight_Delay_Presentation.pptx
@@ -120,35 +120,35 @@
   <p:extLst>
     <p:ext uri="{521415D9-36F7-43E2-AB2F-B90AF26B5E84}">
       <p14:sectionLst xmlns:p14="http://schemas.microsoft.com/office/powerpoint/2010/main">
-        <p14:section name="Introduction" id="{3534b0db-69db-f9ea-c350-df9ccd9c1cd5}">
+        <p14:section name="Introduction" id="{31d76b9d-1ff7-0622-3365-e7f7dade410b}">
           <p14:sldIdLst>
             <p14:sldId id="256"/>
             <p14:sldId id="257"/>
             <p14:sldId id="258"/>
           </p14:sldIdLst>
         </p14:section>
-        <p14:section name="Data and architecture" id="{d833b33e-e11f-abe3-9f74-b2dd61a93cf2}">
+        <p14:section name="Data and architecture" id="{082d4b23-6e2f-e58b-206e-8b1b0eea222e}">
           <p14:sldIdLst>
             <p14:sldId id="259"/>
             <p14:sldId id="260"/>
             <p14:sldId id="261"/>
           </p14:sldIdLst>
         </p14:section>
-        <p14:section name="Method" id="{e7ee491b-a31a-5745-0f59-a5802e0f42af}">
+        <p14:section name="Method" id="{4dd0b947-594b-8ef1-7268-3d04f8cd707c}">
           <p14:sldIdLst>
             <p14:sldId id="262"/>
             <p14:sldId id="263"/>
             <p14:sldId id="264"/>
           </p14:sldIdLst>
         </p14:section>
-        <p14:section name="Results" id="{865d2e3f-08bc-8974-6198-050a87a8cbd0}">
+        <p14:section name="Results" id="{6a0addf2-b1f0-fb82-da54-88cfe6173d5d}">
           <p14:sldIdLst>
             <p14:sldId id="265"/>
             <p14:sldId id="266"/>
             <p14:sldId id="267"/>
           </p14:sldIdLst>
         </p14:section>
-        <p14:section name="Close" id="{0c05397b-3a01-3aa6-f9cb-e27daa5c5ac9}">
+        <p14:section name="Close" id="{974fd555-f846-9ebe-6b30-2dc8f5880a6a}">
           <p14:sldIdLst>
             <p14:sldId id="268"/>
             <p14:sldId id="269"/>
@@ -8942,7 +8942,7 @@
                   <a:schemeClr val="accent6"/>
                 </a:solidFill>
               </a:rPr>
-              <a:t>Google Colab · PySpark 3.5 · Spark SQL / DataFrames for processing · Spark MLlib for modelling</a:t>
+              <a:t>Google Colab · PySpark 4.0 · Spark SQL / DataFrames for processing · Spark MLlib for modelling</a:t>
             </a:r>
             <a:endParaRPr lang="en-US" sz="1400" dirty="0"/>
           </a:p>

</xml_diff>

<commit_message>
Fill report and deck with the full-run results
- results/: figures and report_placeholders.json extracted from the
  completed Colab run (7,001,619 flights; GBT best: F1 0.479, ROC-AUC 0.735)
- notebook/executed/: the full-run notebook with outputs
- report: CHECK notes replaced with interpretation of the real results
  (EDA patterns, model comparison, permutation importance, temporal drop,
  scaling), permutation-importance figure added, trimmed to ~2,190 words
- deck: real-result speaker notes, image fallbacks when CSV tables are
  absent, scale-out stat uses the aggregation speed-up

Co-Authored-By: Claude Opus 5.5 <noreply@anthropic.com>
Claude-Session: https://claude.ai/code/session_013cmZjtFTpWtFMxYtK982h3
</commit_message>
<xml_diff>
--- a/bdmla-flight-delay/presentation/BDMLA_CW1_Flight_Delay_Presentation.pptx
+++ b/bdmla-flight-delay/presentation/BDMLA_CW1_Flight_Delay_Presentation.pptx
@@ -120,35 +120,35 @@
   <p:extLst>
     <p:ext uri="{521415D9-36F7-43E2-AB2F-B90AF26B5E84}">
       <p14:sectionLst xmlns:p14="http://schemas.microsoft.com/office/powerpoint/2010/main">
-        <p14:section name="Introduction" id="{31d76b9d-1ff7-0622-3365-e7f7dade410b}">
+        <p14:section name="Introduction" id="{0a6c5759-1ed5-09d0-c316-3bd99e604607}">
           <p14:sldIdLst>
             <p14:sldId id="256"/>
             <p14:sldId id="257"/>
             <p14:sldId id="258"/>
           </p14:sldIdLst>
         </p14:section>
-        <p14:section name="Data and architecture" id="{082d4b23-6e2f-e58b-206e-8b1b0eea222e}">
+        <p14:section name="Data and architecture" id="{e9ad983b-bccf-c4f1-91be-5ef9df1b1819}">
           <p14:sldIdLst>
             <p14:sldId id="259"/>
             <p14:sldId id="260"/>
             <p14:sldId id="261"/>
           </p14:sldIdLst>
         </p14:section>
-        <p14:section name="Method" id="{4dd0b947-594b-8ef1-7268-3d04f8cd707c}">
+        <p14:section name="Method" id="{3a71d25a-3b1c-5ec3-021c-e6856b45bc07}">
           <p14:sldIdLst>
             <p14:sldId id="262"/>
             <p14:sldId id="263"/>
             <p14:sldId id="264"/>
           </p14:sldIdLst>
         </p14:section>
-        <p14:section name="Results" id="{6a0addf2-b1f0-fb82-da54-88cfe6173d5d}">
+        <p14:section name="Results" id="{20521826-bdab-b861-96aa-441c76d9a310}">
           <p14:sldIdLst>
             <p14:sldId id="265"/>
             <p14:sldId id="266"/>
             <p14:sldId id="267"/>
           </p14:sldIdLst>
         </p14:section>
-        <p14:section name="Close" id="{974fd555-f846-9ebe-6b30-2dc8f5880a6a}">
+        <p14:section name="Close" id="{785412b3-6dfb-a21e-f73b-7ccbcbe5b5e2}">
           <p14:sldIdLst>
             <p14:sldId id="268"/>
             <p14:sldId id="269"/>
@@ -161,6 +161,1137 @@
     </p:ext>
   </p:extLst>
 </p:presentation>
+</file>
+
+<file path=ppt/charts/chart1.xml><?xml version="1.0" encoding="utf-8"?>
+<c:chartSpace xmlns:c="http://schemas.openxmlformats.org/drawingml/2006/chart" xmlns:a="http://schemas.openxmlformats.org/drawingml/2006/main" xmlns:r="http://schemas.openxmlformats.org/officeDocument/2006/relationships">
+  <c:date1904 val="0"/>
+  <c:roundedCorners val="1"/>
+  <c:chart>
+    <c:title>
+      <c:tx>
+        <c:rich>
+          <a:bodyPr/>
+          <a:lstStyle/>
+          <a:p>
+            <a:pPr>
+              <a:defRPr sz="1300" b="0" i="0" u="none" strike="noStrike">
+                <a:solidFill>
+                  <a:srgbClr val="0B1F3A"/>
+                </a:solidFill>
+                <a:latin typeface="+mn-lt"/>
+              </a:defRPr>
+            </a:pPr>
+            <a:r>
+              <a:rPr sz="1300" b="0" i="0" u="none" strike="noStrike">
+                <a:solidFill>
+                  <a:srgbClr val="0B1F3A"/>
+                </a:solidFill>
+                <a:latin typeface="+mn-lt"/>
+              </a:rPr>
+              <a:t>Cleaning funnel (rows remaining)</a:t>
+            </a:r>
+          </a:p>
+        </c:rich>
+      </c:tx>
+      <c:layout/>
+      <c:overlay val="0"/>
+    </c:title>
+    <c:autoTitleDeleted val="0"/>
+    <c:plotArea>
+      <c:layout/>
+      <c:barChart>
+        <c:barDir val="bar"/>
+        <c:grouping val="clustered"/>
+        <c:varyColors val="0"/>
+        <c:ser>
+          <c:idx val="0"/>
+          <c:order val="0"/>
+          <c:tx>
+            <c:strRef>
+              <c:f>Sheet1!$B$1</c:f>
+              <c:strCache>
+                <c:ptCount val="1"/>
+                <c:pt idx="0">
+                  <c:v>Rows</c:v>
+                </c:pt>
+              </c:strCache>
+            </c:strRef>
+          </c:tx>
+          <c:spPr>
+            <a:solidFill>
+              <a:srgbClr val="2A78D6"/>
+            </a:solidFill>
+            <a:effectLst/>
+          </c:spPr>
+          <c:invertIfNegative val="0"/>
+          <c:dLbls>
+            <c:numFmt formatCode="#,##0" sourceLinked="0"/>
+            <c:txPr>
+              <a:bodyPr/>
+              <a:lstStyle/>
+              <a:p>
+                <a:pPr>
+                  <a:defRPr b="0" i="0" strike="noStrike" sz="1000" u="none">
+                    <a:solidFill>
+                      <a:srgbClr val="0B1F3A"/>
+                    </a:solidFill>
+                    <a:latin typeface="+mn-lt"/>
+                  </a:defRPr>
+                </a:pPr>
+              </a:p>
+            </c:txPr>
+            <c:showLegendKey val="0"/>
+            <c:showVal val="1"/>
+            <c:showCatName val="0"/>
+            <c:showSerName val="0"/>
+            <c:showPercent val="0"/>
+            <c:showBubbleSize val="0"/>
+            <c:showLeaderLines val="0"/>
+          </c:dLbls>
+          <c:cat>
+            <c:multiLvlStrRef>
+              <c:f>Sheet1!$A$2:$A$7</c:f>
+              <c:multiLvlStrCache>
+                <c:ptCount val="6"/>
+                <c:lvl>
+                  <c:pt idx="0">
+                    <c:v>Raw flights (12 files)</c:v>
+                  </c:pt>
+                  <c:pt idx="1">
+                    <c:v>Remove cancelled</c:v>
+                  </c:pt>
+                  <c:pt idx="2">
+                    <c:v>Remove diverted</c:v>
+                  </c:pt>
+                  <c:pt idx="3">
+                    <c:v>Remove null ARR_DELAY</c:v>
+                  </c:pt>
+                  <c:pt idx="4">
+                    <c:v>Remove duplicates</c:v>
+                  </c:pt>
+                  <c:pt idx="5">
+                    <c:v>Remove invalid schedule values</c:v>
+                  </c:pt>
+                </c:lvl>
+              </c:multiLvlStrCache>
+            </c:multiLvlStrRef>
+          </c:cat>
+          <c:val>
+            <c:numRef>
+              <c:f>Sheet1!$B$2:$B$7</c:f>
+              <c:numCache>
+                <c:formatCode>General</c:formatCode>
+                <c:ptCount val="6"/>
+                <c:pt idx="0">
+                  <c:v>7001619</c:v>
+                </c:pt>
+                <c:pt idx="1">
+                  <c:v>6898743</c:v>
+                </c:pt>
+                <c:pt idx="2">
+                  <c:v>6879485</c:v>
+                </c:pt>
+                <c:pt idx="3">
+                  <c:v>6879484</c:v>
+                </c:pt>
+                <c:pt idx="4">
+                  <c:v>6879484</c:v>
+                </c:pt>
+                <c:pt idx="5">
+                  <c:v>6879483</c:v>
+                </c:pt>
+              </c:numCache>
+            </c:numRef>
+          </c:val>
+        </c:ser>
+        <c:dLbls>
+          <c:numFmt formatCode="#,##0" sourceLinked="0"/>
+          <c:txPr>
+            <a:bodyPr/>
+            <a:lstStyle/>
+            <a:p>
+              <a:pPr>
+                <a:defRPr b="0" i="0" strike="noStrike" sz="1000" u="none">
+                  <a:solidFill>
+                    <a:srgbClr val="0B1F3A"/>
+                  </a:solidFill>
+                  <a:latin typeface="+mn-lt"/>
+                </a:defRPr>
+              </a:pPr>
+            </a:p>
+          </c:txPr>
+          <c:showLegendKey val="0"/>
+          <c:showVal val="1"/>
+          <c:showCatName val="0"/>
+          <c:showSerName val="0"/>
+          <c:showPercent val="0"/>
+          <c:showBubbleSize val="0"/>
+          <c:showLeaderLines val="0"/>
+        </c:dLbls>
+        <c:gapWidth val="45"/>
+        <c:overlap val="0"/>
+        <c:axId val="2094734554"/>
+        <c:axId val="2094734552"/>
+        <c:axId val="2094734556"/>
+      </c:barChart>
+      <c:catAx>
+        <c:axId val="2094734554"/>
+        <c:scaling>
+          <c:orientation val="maxMin"/>
+        </c:scaling>
+        <c:delete val="0"/>
+        <c:axPos val="l"/>
+        <c:numFmt formatCode="General" sourceLinked="1"/>
+        <c:majorTickMark val="out"/>
+        <c:minorTickMark val="none"/>
+        <c:tickLblPos val="nextTo"/>
+        <c:spPr>
+          <a:ln w="12700" cap="flat">
+            <a:noFill/>
+            <a:prstDash val="solid"/>
+            <a:round/>
+          </a:ln>
+        </c:spPr>
+        <c:txPr>
+          <a:bodyPr/>
+          <a:lstStyle/>
+          <a:p>
+            <a:pPr>
+              <a:defRPr sz="1100" b="0" i="0" u="none" strike="noStrike">
+                <a:solidFill>
+                  <a:srgbClr val="5C6B7A"/>
+                </a:solidFill>
+                <a:latin typeface="+mn-lt"/>
+              </a:defRPr>
+            </a:pPr>
+            <a:endParaRPr lang="en-US"/>
+          </a:p>
+        </c:txPr>
+        <c:crossAx val="2094734552"/>
+        <c:crosses val="autoZero"/>
+        <c:auto val="1"/>
+        <c:lblAlgn val="ctr"/>
+        <c:noMultiLvlLbl val="1"/>
+      </c:catAx>
+      <c:valAx>
+        <c:axId val="2094734552"/>
+        <c:scaling>
+          <c:orientation val="minMax"/>
+        </c:scaling>
+        <c:delete val="1"/>
+        <c:axPos val="b"/>
+        <c:numFmt formatCode="General" sourceLinked="0"/>
+        <c:majorTickMark val="out"/>
+        <c:minorTickMark val="none"/>
+        <c:tickLblPos val="low"/>
+        <c:spPr>
+          <a:ln w="12700" cap="flat">
+            <a:noFill/>
+            <a:prstDash val="solid"/>
+            <a:round/>
+          </a:ln>
+        </c:spPr>
+        <c:txPr>
+          <a:bodyPr/>
+          <a:lstStyle/>
+          <a:p>
+            <a:pPr>
+              <a:defRPr sz="1000" b="0" i="0" u="none" strike="noStrike">
+                <a:solidFill>
+                  <a:srgbClr val="5C6B7A"/>
+                </a:solidFill>
+                <a:latin typeface="+mn-lt"/>
+              </a:defRPr>
+            </a:pPr>
+            <a:endParaRPr lang="en-US"/>
+          </a:p>
+        </c:txPr>
+        <c:crossAx val="2094734554"/>
+        <c:crosses val="autoZero"/>
+        <c:crossBetween val="between"/>
+      </c:valAx>
+      <c:spPr>
+        <a:noFill/>
+        <a:ln>
+          <a:noFill/>
+        </a:ln>
+        <a:effectLst/>
+      </c:spPr>
+    </c:plotArea>
+    <c:plotVisOnly val="1"/>
+    <c:dispBlanksAs val="span"/>
+  </c:chart>
+  <c:spPr>
+    <a:noFill/>
+    <a:ln>
+      <a:noFill/>
+    </a:ln>
+    <a:effectLst/>
+  </c:spPr>
+  <c:externalData r:id="rId1">
+    <c:autoUpdate val="0"/>
+  </c:externalData>
+</c:chartSpace>
+</file>
+
+<file path=ppt/charts/chart2.xml><?xml version="1.0" encoding="utf-8"?>
+<c:chartSpace xmlns:c="http://schemas.openxmlformats.org/drawingml/2006/chart" xmlns:a="http://schemas.openxmlformats.org/drawingml/2006/main" xmlns:r="http://schemas.openxmlformats.org/officeDocument/2006/relationships">
+  <c:date1904 val="0"/>
+  <c:roundedCorners val="1"/>
+  <c:chart>
+    <c:title>
+      <c:tx>
+        <c:rich>
+          <a:bodyPr/>
+          <a:lstStyle/>
+          <a:p>
+            <a:pPr>
+              <a:defRPr sz="1300" b="0" i="0" u="none" strike="noStrike">
+                <a:solidFill>
+                  <a:srgbClr val="0B1F3A"/>
+                </a:solidFill>
+                <a:latin typeface="+mn-lt"/>
+              </a:defRPr>
+            </a:pPr>
+            <a:r>
+              <a:rPr sz="1300" b="0" i="0" u="none" strike="noStrike">
+                <a:solidFill>
+                  <a:srgbClr val="0B1F3A"/>
+                </a:solidFill>
+                <a:latin typeface="+mn-lt"/>
+              </a:rPr>
+              <a:t>Test-set metrics (delayed = positive class)</a:t>
+            </a:r>
+          </a:p>
+        </c:rich>
+      </c:tx>
+      <c:layout/>
+      <c:overlay val="0"/>
+    </c:title>
+    <c:autoTitleDeleted val="0"/>
+    <c:plotArea>
+      <c:layout/>
+      <c:barChart>
+        <c:barDir val="col"/>
+        <c:grouping val="clustered"/>
+        <c:varyColors val="0"/>
+        <c:ser>
+          <c:idx val="0"/>
+          <c:order val="0"/>
+          <c:tx>
+            <c:strRef>
+              <c:f>Sheet1!$B$1</c:f>
+              <c:strCache>
+                <c:ptCount val="1"/>
+                <c:pt idx="0">
+                  <c:v>Logistic Regression</c:v>
+                </c:pt>
+              </c:strCache>
+            </c:strRef>
+          </c:tx>
+          <c:spPr>
+            <a:solidFill>
+              <a:srgbClr val="2A78D6"/>
+            </a:solidFill>
+            <a:effectLst/>
+          </c:spPr>
+          <c:invertIfNegative val="0"/>
+          <c:dLbls>
+            <c:numFmt formatCode="#,##0" sourceLinked="0"/>
+            <c:txPr>
+              <a:bodyPr/>
+              <a:lstStyle/>
+              <a:p>
+                <a:pPr>
+                  <a:defRPr b="0" i="0" strike="noStrike" sz="1000" u="none">
+                    <a:solidFill>
+                      <a:srgbClr val="0B1F3A"/>
+                    </a:solidFill>
+                    <a:latin typeface="+mn-lt"/>
+                  </a:defRPr>
+                </a:pPr>
+              </a:p>
+            </c:txPr>
+            <c:showLegendKey val="0"/>
+            <c:showVal val="0"/>
+            <c:showCatName val="0"/>
+            <c:showSerName val="0"/>
+            <c:showPercent val="0"/>
+            <c:showBubbleSize val="0"/>
+            <c:showLeaderLines val="0"/>
+          </c:dLbls>
+          <c:cat>
+            <c:multiLvlStrRef>
+              <c:f>Sheet1!$A$2:$A$6</c:f>
+              <c:multiLvlStrCache>
+                <c:ptCount val="5"/>
+                <c:lvl>
+                  <c:pt idx="0">
+                    <c:v>Precision</c:v>
+                  </c:pt>
+                  <c:pt idx="1">
+                    <c:v>Recall</c:v>
+                  </c:pt>
+                  <c:pt idx="2">
+                    <c:v>F1</c:v>
+                  </c:pt>
+                  <c:pt idx="3">
+                    <c:v>ROC-AUC</c:v>
+                  </c:pt>
+                  <c:pt idx="4">
+                    <c:v>PR-AUC</c:v>
+                  </c:pt>
+                </c:lvl>
+              </c:multiLvlStrCache>
+            </c:multiLvlStrRef>
+          </c:cat>
+          <c:val>
+            <c:numRef>
+              <c:f>Sheet1!$B$2:$B$6</c:f>
+              <c:numCache>
+                <c:formatCode>General</c:formatCode>
+                <c:ptCount val="5"/>
+                <c:pt idx="0">
+                  <c:v>0.325</c:v>
+                </c:pt>
+                <c:pt idx="1">
+                  <c:v>0.638</c:v>
+                </c:pt>
+                <c:pt idx="2">
+                  <c:v>0.431</c:v>
+                </c:pt>
+                <c:pt idx="3">
+                  <c:v>0.676</c:v>
+                </c:pt>
+                <c:pt idx="4">
+                  <c:v>0.368</c:v>
+                </c:pt>
+              </c:numCache>
+            </c:numRef>
+          </c:val>
+        </c:ser>
+        <c:ser>
+          <c:idx val="1"/>
+          <c:order val="1"/>
+          <c:tx>
+            <c:strRef>
+              <c:f>Sheet1!$C$1</c:f>
+              <c:strCache>
+                <c:ptCount val="1"/>
+                <c:pt idx="0">
+                  <c:v>Random Forest</c:v>
+                </c:pt>
+              </c:strCache>
+            </c:strRef>
+          </c:tx>
+          <c:spPr>
+            <a:solidFill>
+              <a:srgbClr val="EB6834"/>
+            </a:solidFill>
+            <a:effectLst/>
+          </c:spPr>
+          <c:invertIfNegative val="0"/>
+          <c:dLbls>
+            <c:numFmt formatCode="#,##0" sourceLinked="0"/>
+            <c:txPr>
+              <a:bodyPr/>
+              <a:lstStyle/>
+              <a:p>
+                <a:pPr>
+                  <a:defRPr b="0" i="0" strike="noStrike" sz="1000" u="none">
+                    <a:solidFill>
+                      <a:srgbClr val="0B1F3A"/>
+                    </a:solidFill>
+                    <a:latin typeface="+mn-lt"/>
+                  </a:defRPr>
+                </a:pPr>
+              </a:p>
+            </c:txPr>
+            <c:showLegendKey val="0"/>
+            <c:showVal val="0"/>
+            <c:showCatName val="0"/>
+            <c:showSerName val="0"/>
+            <c:showPercent val="0"/>
+            <c:showBubbleSize val="0"/>
+            <c:showLeaderLines val="0"/>
+          </c:dLbls>
+          <c:cat>
+            <c:multiLvlStrRef>
+              <c:f>Sheet1!$A$2:$A$6</c:f>
+              <c:multiLvlStrCache>
+                <c:ptCount val="5"/>
+                <c:lvl>
+                  <c:pt idx="0">
+                    <c:v>Precision</c:v>
+                  </c:pt>
+                  <c:pt idx="1">
+                    <c:v>Recall</c:v>
+                  </c:pt>
+                  <c:pt idx="2">
+                    <c:v>F1</c:v>
+                  </c:pt>
+                  <c:pt idx="3">
+                    <c:v>ROC-AUC</c:v>
+                  </c:pt>
+                  <c:pt idx="4">
+                    <c:v>PR-AUC</c:v>
+                  </c:pt>
+                </c:lvl>
+              </c:multiLvlStrCache>
+            </c:multiLvlStrRef>
+          </c:cat>
+          <c:val>
+            <c:numRef>
+              <c:f>Sheet1!$C$2:$C$6</c:f>
+              <c:numCache>
+                <c:formatCode>General</c:formatCode>
+                <c:ptCount val="5"/>
+                <c:pt idx="0">
+                  <c:v>0.362</c:v>
+                </c:pt>
+                <c:pt idx="1">
+                  <c:v>0.63</c:v>
+                </c:pt>
+                <c:pt idx="2">
+                  <c:v>0.46</c:v>
+                </c:pt>
+                <c:pt idx="3">
+                  <c:v>0.715</c:v>
+                </c:pt>
+                <c:pt idx="4">
+                  <c:v>0.457</c:v>
+                </c:pt>
+              </c:numCache>
+            </c:numRef>
+          </c:val>
+        </c:ser>
+        <c:ser>
+          <c:idx val="2"/>
+          <c:order val="2"/>
+          <c:tx>
+            <c:strRef>
+              <c:f>Sheet1!$D$1</c:f>
+              <c:strCache>
+                <c:ptCount val="1"/>
+                <c:pt idx="0">
+                  <c:v>Gradient-Boosted Trees</c:v>
+                </c:pt>
+              </c:strCache>
+            </c:strRef>
+          </c:tx>
+          <c:spPr>
+            <a:solidFill>
+              <a:srgbClr val="1BAF7A"/>
+            </a:solidFill>
+            <a:effectLst/>
+          </c:spPr>
+          <c:invertIfNegative val="0"/>
+          <c:dLbls>
+            <c:numFmt formatCode="#,##0" sourceLinked="0"/>
+            <c:txPr>
+              <a:bodyPr/>
+              <a:lstStyle/>
+              <a:p>
+                <a:pPr>
+                  <a:defRPr b="0" i="0" strike="noStrike" sz="1000" u="none">
+                    <a:solidFill>
+                      <a:srgbClr val="0B1F3A"/>
+                    </a:solidFill>
+                    <a:latin typeface="+mn-lt"/>
+                  </a:defRPr>
+                </a:pPr>
+              </a:p>
+            </c:txPr>
+            <c:showLegendKey val="0"/>
+            <c:showVal val="0"/>
+            <c:showCatName val="0"/>
+            <c:showSerName val="0"/>
+            <c:showPercent val="0"/>
+            <c:showBubbleSize val="0"/>
+            <c:showLeaderLines val="0"/>
+          </c:dLbls>
+          <c:cat>
+            <c:multiLvlStrRef>
+              <c:f>Sheet1!$A$2:$A$6</c:f>
+              <c:multiLvlStrCache>
+                <c:ptCount val="5"/>
+                <c:lvl>
+                  <c:pt idx="0">
+                    <c:v>Precision</c:v>
+                  </c:pt>
+                  <c:pt idx="1">
+                    <c:v>Recall</c:v>
+                  </c:pt>
+                  <c:pt idx="2">
+                    <c:v>F1</c:v>
+                  </c:pt>
+                  <c:pt idx="3">
+                    <c:v>ROC-AUC</c:v>
+                  </c:pt>
+                  <c:pt idx="4">
+                    <c:v>PR-AUC</c:v>
+                  </c:pt>
+                </c:lvl>
+              </c:multiLvlStrCache>
+            </c:multiLvlStrRef>
+          </c:cat>
+          <c:val>
+            <c:numRef>
+              <c:f>Sheet1!$D$2:$D$6</c:f>
+              <c:numCache>
+                <c:formatCode>General</c:formatCode>
+                <c:ptCount val="5"/>
+                <c:pt idx="0">
+                  <c:v>0.4</c:v>
+                </c:pt>
+                <c:pt idx="1">
+                  <c:v>0.598</c:v>
+                </c:pt>
+                <c:pt idx="2">
+                  <c:v>0.479</c:v>
+                </c:pt>
+                <c:pt idx="3">
+                  <c:v>0.735</c:v>
+                </c:pt>
+                <c:pt idx="4">
+                  <c:v>0.482</c:v>
+                </c:pt>
+              </c:numCache>
+            </c:numRef>
+          </c:val>
+        </c:ser>
+        <c:dLbls>
+          <c:numFmt formatCode="#,##0" sourceLinked="0"/>
+          <c:txPr>
+            <a:bodyPr/>
+            <a:lstStyle/>
+            <a:p>
+              <a:pPr>
+                <a:defRPr b="0" i="0" strike="noStrike" sz="1000" u="none">
+                  <a:solidFill>
+                    <a:srgbClr val="0B1F3A"/>
+                  </a:solidFill>
+                  <a:latin typeface="+mn-lt"/>
+                </a:defRPr>
+              </a:pPr>
+            </a:p>
+          </c:txPr>
+          <c:showLegendKey val="0"/>
+          <c:showVal val="0"/>
+          <c:showCatName val="0"/>
+          <c:showSerName val="0"/>
+          <c:showPercent val="0"/>
+          <c:showBubbleSize val="0"/>
+          <c:showLeaderLines val="0"/>
+        </c:dLbls>
+        <c:gapWidth val="60"/>
+        <c:overlap val="0"/>
+        <c:axId val="2094734554"/>
+        <c:axId val="2094734552"/>
+        <c:axId val="2094734556"/>
+      </c:barChart>
+      <c:catAx>
+        <c:axId val="2094734554"/>
+        <c:scaling>
+          <c:orientation val="minMax"/>
+        </c:scaling>
+        <c:delete val="0"/>
+        <c:axPos val="b"/>
+        <c:numFmt formatCode="General" sourceLinked="1"/>
+        <c:majorTickMark val="out"/>
+        <c:minorTickMark val="none"/>
+        <c:tickLblPos val="low"/>
+        <c:spPr>
+          <a:ln w="12700" cap="flat">
+            <a:noFill/>
+            <a:prstDash val="solid"/>
+            <a:round/>
+          </a:ln>
+        </c:spPr>
+        <c:txPr>
+          <a:bodyPr/>
+          <a:lstStyle/>
+          <a:p>
+            <a:pPr>
+              <a:defRPr sz="1100" b="0" i="0" u="none" strike="noStrike">
+                <a:solidFill>
+                  <a:srgbClr val="5C6B7A"/>
+                </a:solidFill>
+                <a:latin typeface="+mn-lt"/>
+              </a:defRPr>
+            </a:pPr>
+            <a:endParaRPr lang="en-US"/>
+          </a:p>
+        </c:txPr>
+        <c:crossAx val="2094734552"/>
+        <c:crosses val="autoZero"/>
+        <c:auto val="1"/>
+        <c:lblAlgn val="ctr"/>
+        <c:noMultiLvlLbl val="1"/>
+      </c:catAx>
+      <c:valAx>
+        <c:axId val="2094734552"/>
+        <c:scaling>
+          <c:orientation val="minMax"/>
+          <c:max val="1"/>
+          <c:min val="0"/>
+        </c:scaling>
+        <c:delete val="0"/>
+        <c:axPos val="l"/>
+        <c:majorGridlines>
+          <c:spPr>
+            <a:ln w="6350" cap="flat">
+              <a:solidFill>
+                <a:srgbClr val="D9DEE5"/>
+              </a:solidFill>
+              <a:prstDash val="solid"/>
+              <a:round/>
+            </a:ln>
+          </c:spPr>
+        </c:majorGridlines>
+        <c:numFmt formatCode="0.0" sourceLinked="0"/>
+        <c:majorTickMark val="out"/>
+        <c:minorTickMark val="none"/>
+        <c:tickLblPos val="nextTo"/>
+        <c:spPr>
+          <a:ln w="12700" cap="flat">
+            <a:noFill/>
+            <a:prstDash val="solid"/>
+            <a:round/>
+          </a:ln>
+        </c:spPr>
+        <c:txPr>
+          <a:bodyPr/>
+          <a:lstStyle/>
+          <a:p>
+            <a:pPr>
+              <a:defRPr sz="1000" b="0" i="0" u="none" strike="noStrike">
+                <a:solidFill>
+                  <a:srgbClr val="5C6B7A"/>
+                </a:solidFill>
+                <a:latin typeface="+mn-lt"/>
+              </a:defRPr>
+            </a:pPr>
+            <a:endParaRPr lang="en-US"/>
+          </a:p>
+        </c:txPr>
+        <c:crossAx val="2094734554"/>
+        <c:crosses val="autoZero"/>
+        <c:crossBetween val="between"/>
+      </c:valAx>
+      <c:spPr>
+        <a:noFill/>
+        <a:ln>
+          <a:noFill/>
+        </a:ln>
+        <a:effectLst/>
+      </c:spPr>
+    </c:plotArea>
+    <c:legend>
+      <c:legendPos val="b"/>
+      <c:overlay val="0"/>
+      <c:txPr>
+        <a:bodyPr/>
+        <a:lstStyle/>
+        <a:p>
+          <a:pPr>
+            <a:defRPr sz="1100">
+              <a:solidFill>
+                <a:srgbClr val="0B1F3A"/>
+              </a:solidFill>
+              <a:latin typeface="+mn-lt"/>
+              <a:cs typeface="+mn-lt"/>
+            </a:defRPr>
+          </a:pPr>
+          <a:endParaRPr lang="en-US"/>
+        </a:p>
+      </c:txPr>
+    </c:legend>
+    <c:plotVisOnly val="1"/>
+    <c:dispBlanksAs val="span"/>
+  </c:chart>
+  <c:spPr>
+    <a:noFill/>
+    <a:ln>
+      <a:noFill/>
+    </a:ln>
+    <a:effectLst/>
+  </c:spPr>
+  <c:externalData r:id="rId1">
+    <c:autoUpdate val="0"/>
+  </c:externalData>
+</c:chartSpace>
+</file>
+
+<file path=ppt/charts/chart3.xml><?xml version="1.0" encoding="utf-8"?>
+<c:chartSpace xmlns:c="http://schemas.openxmlformats.org/drawingml/2006/chart" xmlns:a="http://schemas.openxmlformats.org/drawingml/2006/main" xmlns:r="http://schemas.openxmlformats.org/officeDocument/2006/relationships">
+  <c:date1904 val="0"/>
+  <c:roundedCorners val="1"/>
+  <c:chart>
+    <c:title>
+      <c:tx>
+        <c:rich>
+          <a:bodyPr/>
+          <a:lstStyle/>
+          <a:p>
+            <a:pPr>
+              <a:defRPr sz="1300" b="0" i="0" u="none" strike="noStrike">
+                <a:solidFill>
+                  <a:srgbClr val="0B1F3A"/>
+                </a:solidFill>
+                <a:latin typeface="+mn-lt"/>
+              </a:defRPr>
+            </a:pPr>
+            <a:r>
+              <a:rPr sz="1300" b="0" i="0" u="none" strike="noStrike">
+                <a:solidFill>
+                  <a:srgbClr val="0B1F3A"/>
+                </a:solidFill>
+                <a:latin typeface="+mn-lt"/>
+              </a:rPr>
+              <a:t>ROC-AUC: random vs temporal test</a:t>
+            </a:r>
+          </a:p>
+        </c:rich>
+      </c:tx>
+      <c:layout/>
+      <c:overlay val="0"/>
+    </c:title>
+    <c:autoTitleDeleted val="0"/>
+    <c:plotArea>
+      <c:layout/>
+      <c:barChart>
+        <c:barDir val="col"/>
+        <c:grouping val="clustered"/>
+        <c:varyColors val="0"/>
+        <c:ser>
+          <c:idx val="0"/>
+          <c:order val="0"/>
+          <c:tx>
+            <c:strRef>
+              <c:f>Sheet1!$B$1</c:f>
+              <c:strCache>
+                <c:ptCount val="1"/>
+                <c:pt idx="0">
+                  <c:v>Random split</c:v>
+                </c:pt>
+              </c:strCache>
+            </c:strRef>
+          </c:tx>
+          <c:spPr>
+            <a:solidFill>
+              <a:srgbClr val="13315C"/>
+            </a:solidFill>
+            <a:effectLst/>
+          </c:spPr>
+          <c:invertIfNegative val="0"/>
+          <c:dLbls>
+            <c:numFmt formatCode="0.000" sourceLinked="0"/>
+            <c:txPr>
+              <a:bodyPr/>
+              <a:lstStyle/>
+              <a:p>
+                <a:pPr>
+                  <a:defRPr b="0" i="0" strike="noStrike" sz="1000" u="none">
+                    <a:solidFill>
+                      <a:srgbClr val="0B1F3A"/>
+                    </a:solidFill>
+                    <a:latin typeface="+mn-lt"/>
+                  </a:defRPr>
+                </a:pPr>
+              </a:p>
+            </c:txPr>
+            <c:showLegendKey val="0"/>
+            <c:showVal val="1"/>
+            <c:showCatName val="0"/>
+            <c:showSerName val="0"/>
+            <c:showPercent val="0"/>
+            <c:showBubbleSize val="0"/>
+            <c:showLeaderLines val="0"/>
+          </c:dLbls>
+          <c:cat>
+            <c:multiLvlStrRef>
+              <c:f>Sheet1!$A$2:$A$4</c:f>
+              <c:multiLvlStrCache>
+                <c:ptCount val="3"/>
+                <c:lvl>
+                  <c:pt idx="0">
+                    <c:v>LR</c:v>
+                  </c:pt>
+                  <c:pt idx="1">
+                    <c:v>RF</c:v>
+                  </c:pt>
+                  <c:pt idx="2">
+                    <c:v>GBT</c:v>
+                  </c:pt>
+                </c:lvl>
+              </c:multiLvlStrCache>
+            </c:multiLvlStrRef>
+          </c:cat>
+          <c:val>
+            <c:numRef>
+              <c:f>Sheet1!$B$2:$B$4</c:f>
+              <c:numCache>
+                <c:formatCode>General</c:formatCode>
+                <c:ptCount val="3"/>
+                <c:pt idx="0">
+                  <c:v>0.676</c:v>
+                </c:pt>
+                <c:pt idx="1">
+                  <c:v>0.715</c:v>
+                </c:pt>
+                <c:pt idx="2">
+                  <c:v>0.735</c:v>
+                </c:pt>
+              </c:numCache>
+            </c:numRef>
+          </c:val>
+        </c:ser>
+        <c:ser>
+          <c:idx val="1"/>
+          <c:order val="1"/>
+          <c:tx>
+            <c:strRef>
+              <c:f>Sheet1!$C$1</c:f>
+              <c:strCache>
+                <c:ptCount val="1"/>
+                <c:pt idx="0">
+                  <c:v>Temporal (Oct-Dec)</c:v>
+                </c:pt>
+              </c:strCache>
+            </c:strRef>
+          </c:tx>
+          <c:spPr>
+            <a:solidFill>
+              <a:srgbClr val="8DA9C4"/>
+            </a:solidFill>
+            <a:effectLst/>
+          </c:spPr>
+          <c:invertIfNegative val="0"/>
+          <c:dLbls>
+            <c:numFmt formatCode="0.000" sourceLinked="0"/>
+            <c:txPr>
+              <a:bodyPr/>
+              <a:lstStyle/>
+              <a:p>
+                <a:pPr>
+                  <a:defRPr b="0" i="0" strike="noStrike" sz="1000" u="none">
+                    <a:solidFill>
+                      <a:srgbClr val="0B1F3A"/>
+                    </a:solidFill>
+                    <a:latin typeface="+mn-lt"/>
+                  </a:defRPr>
+                </a:pPr>
+              </a:p>
+            </c:txPr>
+            <c:showLegendKey val="0"/>
+            <c:showVal val="1"/>
+            <c:showCatName val="0"/>
+            <c:showSerName val="0"/>
+            <c:showPercent val="0"/>
+            <c:showBubbleSize val="0"/>
+            <c:showLeaderLines val="0"/>
+          </c:dLbls>
+          <c:cat>
+            <c:multiLvlStrRef>
+              <c:f>Sheet1!$A$2:$A$4</c:f>
+              <c:multiLvlStrCache>
+                <c:ptCount val="3"/>
+                <c:lvl>
+                  <c:pt idx="0">
+                    <c:v>LR</c:v>
+                  </c:pt>
+                  <c:pt idx="1">
+                    <c:v>RF</c:v>
+                  </c:pt>
+                  <c:pt idx="2">
+                    <c:v>GBT</c:v>
+                  </c:pt>
+                </c:lvl>
+              </c:multiLvlStrCache>
+            </c:multiLvlStrRef>
+          </c:cat>
+          <c:val>
+            <c:numRef>
+              <c:f>Sheet1!$C$2:$C$4</c:f>
+              <c:numCache>
+                <c:formatCode>General</c:formatCode>
+                <c:ptCount val="3"/>
+                <c:pt idx="0">
+                  <c:v>0.603</c:v>
+                </c:pt>
+                <c:pt idx="1">
+                  <c:v>0.672</c:v>
+                </c:pt>
+                <c:pt idx="2">
+                  <c:v>0.679</c:v>
+                </c:pt>
+              </c:numCache>
+            </c:numRef>
+          </c:val>
+        </c:ser>
+        <c:dLbls>
+          <c:numFmt formatCode="0.000" sourceLinked="0"/>
+          <c:txPr>
+            <a:bodyPr/>
+            <a:lstStyle/>
+            <a:p>
+              <a:pPr>
+                <a:defRPr b="0" i="0" strike="noStrike" sz="1000" u="none">
+                  <a:solidFill>
+                    <a:srgbClr val="0B1F3A"/>
+                  </a:solidFill>
+                  <a:latin typeface="+mn-lt"/>
+                </a:defRPr>
+              </a:pPr>
+            </a:p>
+          </c:txPr>
+          <c:showLegendKey val="0"/>
+          <c:showVal val="1"/>
+          <c:showCatName val="0"/>
+          <c:showSerName val="0"/>
+          <c:showPercent val="0"/>
+          <c:showBubbleSize val="0"/>
+          <c:showLeaderLines val="0"/>
+        </c:dLbls>
+        <c:gapWidth val="60"/>
+        <c:overlap val="0"/>
+        <c:axId val="2094734554"/>
+        <c:axId val="2094734552"/>
+        <c:axId val="2094734556"/>
+      </c:barChart>
+      <c:catAx>
+        <c:axId val="2094734554"/>
+        <c:scaling>
+          <c:orientation val="minMax"/>
+        </c:scaling>
+        <c:delete val="0"/>
+        <c:axPos val="b"/>
+        <c:numFmt formatCode="General" sourceLinked="1"/>
+        <c:majorTickMark val="out"/>
+        <c:minorTickMark val="none"/>
+        <c:tickLblPos val="low"/>
+        <c:spPr>
+          <a:ln w="12700" cap="flat">
+            <a:noFill/>
+            <a:prstDash val="solid"/>
+            <a:round/>
+          </a:ln>
+        </c:spPr>
+        <c:txPr>
+          <a:bodyPr/>
+          <a:lstStyle/>
+          <a:p>
+            <a:pPr>
+              <a:defRPr sz="1100" b="0" i="0" u="none" strike="noStrike">
+                <a:solidFill>
+                  <a:srgbClr val="5C6B7A"/>
+                </a:solidFill>
+                <a:latin typeface="+mn-lt"/>
+              </a:defRPr>
+            </a:pPr>
+            <a:endParaRPr lang="en-US"/>
+          </a:p>
+        </c:txPr>
+        <c:crossAx val="2094734552"/>
+        <c:crosses val="autoZero"/>
+        <c:auto val="1"/>
+        <c:lblAlgn val="ctr"/>
+        <c:noMultiLvlLbl val="1"/>
+      </c:catAx>
+      <c:valAx>
+        <c:axId val="2094734552"/>
+        <c:scaling>
+          <c:orientation val="minMax"/>
+          <c:max val="1"/>
+          <c:min val="0.5"/>
+        </c:scaling>
+        <c:delete val="0"/>
+        <c:axPos val="l"/>
+        <c:majorGridlines>
+          <c:spPr>
+            <a:ln w="6350" cap="flat">
+              <a:solidFill>
+                <a:srgbClr val="D9DEE5"/>
+              </a:solidFill>
+              <a:prstDash val="solid"/>
+              <a:round/>
+            </a:ln>
+          </c:spPr>
+        </c:majorGridlines>
+        <c:numFmt formatCode="0.0" sourceLinked="0"/>
+        <c:majorTickMark val="out"/>
+        <c:minorTickMark val="none"/>
+        <c:tickLblPos val="nextTo"/>
+        <c:spPr>
+          <a:ln w="12700" cap="flat">
+            <a:noFill/>
+            <a:prstDash val="solid"/>
+            <a:round/>
+          </a:ln>
+        </c:spPr>
+        <c:txPr>
+          <a:bodyPr/>
+          <a:lstStyle/>
+          <a:p>
+            <a:pPr>
+              <a:defRPr sz="1000" b="0" i="0" u="none" strike="noStrike">
+                <a:solidFill>
+                  <a:srgbClr val="5C6B7A"/>
+                </a:solidFill>
+                <a:latin typeface="+mn-lt"/>
+              </a:defRPr>
+            </a:pPr>
+            <a:endParaRPr lang="en-US"/>
+          </a:p>
+        </c:txPr>
+        <c:crossAx val="2094734554"/>
+        <c:crosses val="autoZero"/>
+        <c:crossBetween val="between"/>
+      </c:valAx>
+      <c:spPr>
+        <a:noFill/>
+        <a:ln>
+          <a:noFill/>
+        </a:ln>
+        <a:effectLst/>
+      </c:spPr>
+    </c:plotArea>
+    <c:legend>
+      <c:legendPos val="b"/>
+      <c:overlay val="0"/>
+      <c:txPr>
+        <a:bodyPr/>
+        <a:lstStyle/>
+        <a:p>
+          <a:pPr>
+            <a:defRPr sz="1100">
+              <a:solidFill>
+                <a:srgbClr val="0B1F3A"/>
+              </a:solidFill>
+              <a:latin typeface="+mn-lt"/>
+              <a:cs typeface="+mn-lt"/>
+            </a:defRPr>
+          </a:pPr>
+          <a:endParaRPr lang="en-US"/>
+        </a:p>
+      </c:txPr>
+    </c:legend>
+    <c:plotVisOnly val="1"/>
+    <c:dispBlanksAs val="span"/>
+  </c:chart>
+  <c:spPr>
+    <a:noFill/>
+    <a:ln>
+      <a:noFill/>
+    </a:ln>
+    <a:effectLst/>
+  </c:spPr>
+  <c:externalData r:id="rId1">
+    <c:autoUpdate val="0"/>
+  </c:externalData>
+</c:chartSpace>
 </file>
 
 <file path=ppt/notesMasters/notesMaster1.xml><?xml version="1.0" encoding="utf-8"?>
@@ -646,7 +1777,7 @@
           <a:p>
             <a:r>
               <a:rPr lang="en-US" dirty="0"/>
-              <a:t>[6:20-7:15] These are the test results. [BEST_F1_MODEL] had the best F1, [BEST_F1_VALUE], and [BEST_AUC_MODEL] the best ROC-AUC. Notice the last row: a "model" that always says on time gets [BASELINE_ACCURACY] accuracy and catches zero delays. That's why accuracy alone is misleading here, and why I focus on recall, F1 and PR-AUC. On training time, [FASTEST_MODEL] was quickest and [SLOWEST_MODEL] slowest. [CHECK: one sentence on whether the extra accuracy of the tree models is worth the training cost.]</a:t>
+              <a:t>[6:20-7:15] These are the test results. Gradient-Boosted Trees had the best F1, 0.479, and Gradient-Boosted Trees the best ROC-AUC. Notice the last row: a "model" that always says on time gets 77.70% accuracy and catches zero delays. That's why accuracy alone is misleading here, and why I focus on recall, F1 and PR-AUC. On training time, Logistic Regression was quickest and Random Forest slowest. Both tree models clearly beat logistic regression, so the non-linear interactions matter. And boosting wins twice: it's more accurate than the tuned random forest and trains in less than a quarter of the time.</a:t>
             </a:r>
             <a:endParaRPr lang="en-US" dirty="0"/>
           </a:p>
@@ -734,7 +1865,7 @@
           <a:p>
             <a:r>
               <a:rPr lang="en-US" dirty="0"/>
-              <a:t>[7:15-8:05] On the left, the features the boosted model relied on most: [GBT_TOP_FEATURE_1], [GBT_TOP_FEATURE_2] and [GBT_TOP_FEATURE_3]. [CHECK: one sentence on why these make sense, e.g. route and time-of-day history, rotation.] I also checked this with permutation importance, which [agrees / partly agrees]. On the right is the stricter test: train on January to September, predict October to December. A random split lets the model see the same storm days in training and test, so the temporal score is the honest one for real use. [Describe the size of the drop.]</a:t>
+              <a:t>[7:15-8:05] On the left is permutation importance: how much accuracy drops when I shuffle one feature. The two that matter most are the historical delay rate of that airport at that hour, and the scheduled turnaround time, which is exactly the delay-propagation story. Interestingly, the tree's own importance ranking also puts day-of-month and holiday distance near the top, which hints that it memorises specific bad days. The right-hand chart confirms it: train on January to September and predict October to December, and ROC-AUC drops from 0.735 to 0.679 for boosting. Logistic regression collapses because it has never seen those months. The temporal number is the honest one for real use.</a:t>
             </a:r>
             <a:endParaRPr lang="en-US" dirty="0"/>
           </a:p>
@@ -822,7 +1953,7 @@
           <a:p>
             <a:r>
               <a:rPr lang="en-US" dirty="0"/>
-              <a:t>[8:05-8:55] Three things I took away. First, the accuracy trap: doing nothing already scores [BASELINE_ACCURACY], so you have to look at recall and F1. Second, where you set the threshold is really a business decision. If you're positioning spare crews you can live with false alarms, but if you're texting passengers you need precision. Third, accuracy versus cost: [FASTEST_MODEL] trains fastest, and boosting is the hardest to scale. The main limitations are no weather data, possible small leakage from same-day aircraft swaps, and training on a sample because of Colab limits.</a:t>
+              <a:t>[8:05-8:55] Three things I took away. First, the accuracy trap: doing nothing already scores 77.70%, so you have to look at recall and F1. Second, where you set the threshold is really a business decision. If you're positioning spare crews you can live with false alarms, but if you're texting passengers you need precision. Third, accuracy versus cost: Logistic Regression trains fastest, and boosting is the hardest to scale. The main limitations are no weather data, possible small leakage from same-day aircraft swaps, and training on a sample because of Colab limits.</a:t>
             </a:r>
             <a:endParaRPr lang="en-US" dirty="0"/>
           </a:p>
@@ -910,7 +2041,7 @@
           <a:p>
             <a:r>
               <a:rPr lang="en-US" dirty="0"/>
-              <a:t>[8:55-9:40] To wrap up: I built a full, leakage-free Spark pipeline over every 2025 U.S. domestic flight, and [BEST_F1_MODEL] performed best on F1. The biggest lessons were about evaluation, not algorithms: handling the imbalance and choosing the threshold mattered more than chasing accuracy. Next, I would add weather forecasts, which is the biggest missing signal, try XGBoost on GPUs, run the full data on a real cluster, and use Spark streaming to update predictions on the day as earlier flights report delays.</a:t>
+              <a:t>[8:55-9:40] To wrap up: I built a full, leakage-free Spark pipeline over every 2025 U.S. domestic flight, and Gradient-Boosted Trees performed best on F1. The biggest lessons were about evaluation, not algorithms: handling the imbalance and choosing the threshold mattered more than chasing accuracy. Next, I would add weather forecasts, which is the biggest missing signal, try XGBoost on GPUs, run the full data on a real cluster, and use Spark streaming to update predictions on the day as earlier flights report delays.</a:t>
             </a:r>
             <a:endParaRPr lang="en-US" dirty="0"/>
           </a:p>
@@ -1001,7 +2132,7 @@
               <a:t>[9:40-10:00] Thank you, I'm happy to take questions.
 LIKELY QUESTIONS (prepare, don't read):
 - Why not use departure delay? It's only known after the plane leaves, so the model would be useless for planning, and it inflates accuracy (leakage).
-- Why is accuracy not enough? Always predicting "on time" already gets [BASELINE_ACCURACY]; we care about catching delays (recall) without too many false alarms (precision).
+- Why is accuracy not enough? Always predicting "on time" already gets 77.70%; we care about catching delays (recall) without too many false alarms (precision).
 - Why target encoding? Hundreds of airports and thousands of routes; one-hot would explode the feature space and Spark trees need maxBins &gt;= categories. Fitted on training data only.
 - Why did you sample the training data? Colab has 2 cores and ~12 GB RAM; validation and test were always scored in full. On a cluster I'd use everything.
 - How would this scale? Same code, different master URL; LR and RF parallelise well, GBT is sequential across rounds. GPUs via RAPIDS or XGBoost-Spark.
@@ -1094,7 +2225,7 @@
           <a:p>
             <a:r>
               <a:rPr lang="en-US" dirty="0"/>
-              <a:t>[0:20-1:05] Delays are expensive. A U.S. study put the total cost at around 33 billion dollars in 2007 alone, across airlines, passengers and lost demand. The industry uses a simple rule: if you arrive 15 minutes or more after schedule, you are delayed. The Bureau of Transportation Statistics publishes a record for every domestic flight, about [RAW_ROWS] in 2025, which gives us millions of labelled examples. Knowing earlier which flights are at risk helps airlines re-plan crews and aircraft, helps passengers with connections, and helps airports manage peaks.</a:t>
+              <a:t>[0:20-1:05] Delays are expensive. A U.S. study put the total cost at around 33 billion dollars in 2007 alone, across airlines, passengers and lost demand. The industry uses a simple rule: if you arrive 15 minutes or more after schedule, you are delayed. The Bureau of Transportation Statistics publishes a record for every domestic flight, about 7,001,619 in 2025, which gives us millions of labelled examples. Knowing earlier which flights are at risk helps airlines re-plan crews and aircraft, helps passengers with connections, and helps airports manage peaks.</a:t>
             </a:r>
             <a:endParaRPr lang="en-US" dirty="0"/>
           </a:p>
@@ -1270,7 +2401,7 @@
           <a:p>
             <a:r>
               <a:rPr lang="en-US" dirty="0"/>
-              <a:t>[1:45-2:30] The data is the official BTS on-time table. I downloaded all twelve months of 2025, about 3 gigabytes of CSV and [RAW_ROWS] flights. Each file has around 110 columns, but I only load 17, which I'll come back to when I talk about leakage. After cleaning, about [DELAY_RATE] of flights are delayed, so the classes are imbalanced. The chart shows one of the clearest patterns: [CHECK the chart; typically] delays build up through the day, because a late aircraft carries its delay into its next flights.</a:t>
+              <a:t>[1:45-2:30] The data is the official BTS on-time table. I downloaded all twelve months of 2025, about 3 gigabytes of CSV and 7,001,619 flights. Each file has around 110 columns, but I only load 17, which I'll come back to when I talk about leakage. After cleaning, about 22.31% of flights are delayed, so the classes are imbalanced. The chart shows the clearest pattern: only about 9 percent of 5am departures arrive late, but by 7pm it's about a third. Delays build up through the day because a late aircraft carries its delay into its next flights.</a:t>
             </a:r>
             <a:endParaRPr lang="en-US" dirty="0"/>
           </a:p>
@@ -1446,7 +2577,7 @@
           <a:p>
             <a:r>
               <a:rPr lang="en-US" dirty="0"/>
-              <a:t>[3:10-4:00] A quick look under the hood. Spark breaks the job into stages and tasks, one per data partition. In Colab the driver and executor share one machine, but the same code runs on a cluster just by changing the master URL. The changes that mattered most: converting to Parquet once, which made the same query [PARQUET_SPEEDUP] faster; reducing shuffle partitions; broadcasting small lookup tables; and computing all metrics inside Spark. I also ran a small scaling test: going from 1 to [SCALE_MAX_CORES] cores made logistic regression [SCALE_LR_SPEEDUP] faster.</a:t>
+              <a:t>[3:10-4:00] A quick look under the hood. Spark breaks the job into stages and tasks, one per data partition. In Colab the driver and executor share one machine, but the same code runs on a cluster just by changing the master URL. The changes that mattered most: converting to Parquet once, which made the same query 25.1x faster; reducing shuffle partitions; broadcasting small lookup tables; and computing all metrics inside Spark. I also ran a small scaling test: going from 1 to 2 cores made a full scan 2.41x faster. Logistic regression barely changed, because on a small cached sample each iteration is dominated by fixed overhead. Its parallel gradient step pays off with much more data per task, which is what a cluster gives you.</a:t>
             </a:r>
             <a:endParaRPr lang="en-US" dirty="0"/>
           </a:p>
@@ -2721,83 +3852,22 @@
           </a:p>
         </p:txBody>
       </p:sp>
-      <p:sp>
-        <p:nvSpPr>
-          <p:cNvPr id="3" name="ph-metrics"/>
-          <p:cNvSpPr/>
-          <p:nvPr/>
-        </p:nvSpPr>
-        <p:spPr>
-          <a:xfrm>
-            <a:off x="548640" y="1280160"/>
-            <a:ext cx="6675120" cy="4572000"/>
-          </a:xfrm>
-          <a:prstGeom prst="roundRect">
-            <a:avLst>
-              <a:gd name="adj" fmla="val 1200"/>
-            </a:avLst>
-          </a:prstGeom>
-          <a:solidFill>
-            <a:srgbClr val="FFF8DB"/>
-          </a:solidFill>
-          <a:ln w="15875">
-            <a:solidFill>
-              <a:srgbClr val="EDA100"/>
-            </a:solidFill>
-            <a:prstDash val="dash"/>
-          </a:ln>
-        </p:spPr>
-      </p:sp>
-      <p:sp>
-        <p:nvSpPr>
-          <p:cNvPr id="4" name="Text 2"/>
-          <p:cNvSpPr txBox="1"/>
-          <p:nvPr/>
-        </p:nvSpPr>
-        <p:spPr>
-          <a:xfrm>
-            <a:off x="548640" y="1280160"/>
-            <a:ext cx="6675120" cy="4572000"/>
-          </a:xfrm>
-          <a:prstGeom prst="rect">
-            <a:avLst/>
-          </a:prstGeom>
-          <a:noFill/>
-          <a:ln/>
-        </p:spPr>
-        <p:txBody>
-          <a:bodyPr wrap="square" lIns="76200" tIns="76200" rIns="76200" bIns="76200" rtlCol="0" anchor="ctr"/>
-          <a:lstStyle/>
-          <a:p>
-            <a:pPr algn="ctr" indent="0" marL="0">
-              <a:buNone/>
-            </a:pPr>
-            <a:r>
-              <a:rPr lang="en-US" sz="1400" dirty="0">
-                <a:solidFill>
-                  <a:srgbClr val="7F6000"/>
-                </a:solidFill>
-              </a:rPr>
-              <a:t>Native chart: precision, recall, F1, ROC-AUC, PR-AUC per model</a:t>
-            </a:r>
-            <a:endParaRPr lang="en-US" sz="1400" dirty="0"/>
-          </a:p>
-          <a:p>
-            <a:pPr algn="ctr" indent="0" marL="0">
-              <a:buNone/>
-            </a:pPr>
-            <a:r>
-              <a:rPr lang="en-US" sz="1400" dirty="0">
-                <a:solidFill>
-                  <a:srgbClr val="7F6000"/>
-                </a:solidFill>
-              </a:rPr>
-              <a:t>(rebuild with notebook outputs)</a:t>
-            </a:r>
-            <a:endParaRPr lang="en-US" sz="1400" dirty="0"/>
-          </a:p>
-        </p:txBody>
-      </p:sp>
+      <p:graphicFrame>
+        <p:nvGraphicFramePr>
+          <p:cNvPr id="3" name="chart-metrics" descr=""/>
+          <p:cNvGraphicFramePr/>
+          <p:nvPr/>
+        </p:nvGraphicFramePr>
+        <p:xfrm>
+          <a:off x="548640" y="1280160"/>
+          <a:ext cx="6675120" cy="4572000"/>
+        </p:xfrm>
+        <a:graphic xmlns:a="http://schemas.openxmlformats.org/drawingml/2006/main">
+          <a:graphicData uri="http://schemas.openxmlformats.org/drawingml/2006/chart">
+            <c:chart xmlns:c="http://schemas.openxmlformats.org/drawingml/2006/chart" r:id="rId1"/>
+          </a:graphicData>
+        </a:graphic>
+      </p:graphicFrame>
       <p:graphicFrame>
         <p:nvGraphicFramePr>
           <p:cNvPr id="11" name="results-table"/>
@@ -3201,11 +4271,8 @@
                           <a:solidFill>
                             <a:srgbClr val="0B1F3A"/>
                           </a:solidFill>
-                          <a:highlight>
-                            <a:srgbClr val="FFFF00"/>
-                          </a:highlight>
                         </a:rPr>
-                        <a:t>[LR_ACCURACY]</a:t>
+                        <a:t>0.624</a:t>
                       </a:r>
                       <a:endParaRPr lang="en-US" sz="1300" dirty="0"/>
                     </a:p>
@@ -3265,11 +4332,8 @@
                           <a:solidFill>
                             <a:srgbClr val="0B1F3A"/>
                           </a:solidFill>
-                          <a:highlight>
-                            <a:srgbClr val="FFFF00"/>
-                          </a:highlight>
                         </a:rPr>
-                        <a:t>[LR_F1]</a:t>
+                        <a:t>0.431</a:t>
                       </a:r>
                       <a:endParaRPr lang="en-US" sz="1300" dirty="0"/>
                     </a:p>
@@ -3329,11 +4393,8 @@
                           <a:solidFill>
                             <a:srgbClr val="0B1F3A"/>
                           </a:solidFill>
-                          <a:highlight>
-                            <a:srgbClr val="FFFF00"/>
-                          </a:highlight>
                         </a:rPr>
-                        <a:t>[LR_ROC_AUC]</a:t>
+                        <a:t>0.676</a:t>
                       </a:r>
                       <a:endParaRPr lang="en-US" sz="1300" dirty="0"/>
                     </a:p>
@@ -3393,11 +4454,8 @@
                           <a:solidFill>
                             <a:srgbClr val="0B1F3A"/>
                           </a:solidFill>
-                          <a:highlight>
-                            <a:srgbClr val="FFFF00"/>
-                          </a:highlight>
                         </a:rPr>
-                        <a:t>[LR_TRAIN_S]</a:t>
+                        <a:t>47 s</a:t>
                       </a:r>
                       <a:endParaRPr lang="en-US" sz="1300" dirty="0"/>
                     </a:p>
@@ -3520,11 +4578,8 @@
                           <a:solidFill>
                             <a:srgbClr val="0B1F3A"/>
                           </a:solidFill>
-                          <a:highlight>
-                            <a:srgbClr val="FFFF00"/>
-                          </a:highlight>
                         </a:rPr>
-                        <a:t>[RF_ACCURACY]</a:t>
+                        <a:t>0.669</a:t>
                       </a:r>
                       <a:endParaRPr lang="en-US" sz="1300" dirty="0"/>
                     </a:p>
@@ -3584,11 +4639,8 @@
                           <a:solidFill>
                             <a:srgbClr val="0B1F3A"/>
                           </a:solidFill>
-                          <a:highlight>
-                            <a:srgbClr val="FFFF00"/>
-                          </a:highlight>
                         </a:rPr>
-                        <a:t>[RF_F1]</a:t>
+                        <a:t>0.460</a:t>
                       </a:r>
                       <a:endParaRPr lang="en-US" sz="1300" dirty="0"/>
                     </a:p>
@@ -3648,11 +4700,8 @@
                           <a:solidFill>
                             <a:srgbClr val="0B1F3A"/>
                           </a:solidFill>
-                          <a:highlight>
-                            <a:srgbClr val="FFFF00"/>
-                          </a:highlight>
                         </a:rPr>
-                        <a:t>[RF_ROC_AUC]</a:t>
+                        <a:t>0.715</a:t>
                       </a:r>
                       <a:endParaRPr lang="en-US" sz="1300" dirty="0"/>
                     </a:p>
@@ -3712,11 +4761,8 @@
                           <a:solidFill>
                             <a:srgbClr val="0B1F3A"/>
                           </a:solidFill>
-                          <a:highlight>
-                            <a:srgbClr val="FFFF00"/>
-                          </a:highlight>
                         </a:rPr>
-                        <a:t>[RF_TRAIN_S]</a:t>
+                        <a:t>2115 s</a:t>
                       </a:r>
                       <a:endParaRPr lang="en-US" sz="1300" dirty="0"/>
                     </a:p>
@@ -3839,11 +4885,8 @@
                           <a:solidFill>
                             <a:srgbClr val="0B1F3A"/>
                           </a:solidFill>
-                          <a:highlight>
-                            <a:srgbClr val="FFFF00"/>
-                          </a:highlight>
                         </a:rPr>
-                        <a:t>[GBT_ACCURACY]</a:t>
+                        <a:t>0.710</a:t>
                       </a:r>
                       <a:endParaRPr lang="en-US" sz="1300" dirty="0"/>
                     </a:p>
@@ -3903,11 +4946,8 @@
                           <a:solidFill>
                             <a:srgbClr val="0B1F3A"/>
                           </a:solidFill>
-                          <a:highlight>
-                            <a:srgbClr val="FFFF00"/>
-                          </a:highlight>
                         </a:rPr>
-                        <a:t>[GBT_F1]</a:t>
+                        <a:t>0.479</a:t>
                       </a:r>
                       <a:endParaRPr lang="en-US" sz="1300" dirty="0"/>
                     </a:p>
@@ -3967,11 +5007,8 @@
                           <a:solidFill>
                             <a:srgbClr val="0B1F3A"/>
                           </a:solidFill>
-                          <a:highlight>
-                            <a:srgbClr val="FFFF00"/>
-                          </a:highlight>
                         </a:rPr>
-                        <a:t>[GBT_ROC_AUC]</a:t>
+                        <a:t>0.735</a:t>
                       </a:r>
                       <a:endParaRPr lang="en-US" sz="1300" dirty="0"/>
                     </a:p>
@@ -4031,11 +5068,8 @@
                           <a:solidFill>
                             <a:srgbClr val="0B1F3A"/>
                           </a:solidFill>
-                          <a:highlight>
-                            <a:srgbClr val="FFFF00"/>
-                          </a:highlight>
                         </a:rPr>
-                        <a:t>[GBT_TRAIN_S]</a:t>
+                        <a:t>465 s</a:t>
                       </a:r>
                       <a:endParaRPr lang="en-US" sz="1300" dirty="0"/>
                     </a:p>
@@ -4158,11 +5192,8 @@
                           <a:solidFill>
                             <a:srgbClr val="0B1F3A"/>
                           </a:solidFill>
-                          <a:highlight>
-                            <a:srgbClr val="FFFF00"/>
-                          </a:highlight>
                         </a:rPr>
-                        <a:t>[BASELINE_ACCURACY]</a:t>
+                        <a:t>77.70%</a:t>
                       </a:r>
                       <a:endParaRPr lang="en-US" sz="1300" dirty="0"/>
                     </a:p>
@@ -4399,7 +5430,7 @@
       </p:graphicFrame>
       <p:sp>
         <p:nvSpPr>
-          <p:cNvPr id="6" name="Text 3"/>
+          <p:cNvPr id="5" name="Text 1"/>
           <p:cNvSpPr txBox="1"/>
           <p:nvPr/>
         </p:nvSpPr>
@@ -4435,13 +5466,10 @@
             <a:r>
               <a:rPr lang="en-US" sz="1500" b="1" dirty="0">
                 <a:solidFill>
-                  <a:srgbClr val="000000"/>
-                </a:solidFill>
-                <a:highlight>
-                  <a:srgbClr val="FFFF00"/>
-                </a:highlight>
-              </a:rPr>
-              <a:t>[BEST_F1_MODEL]</a:t>
+                  <a:schemeClr val="tx1"/>
+                </a:solidFill>
+              </a:rPr>
+              <a:t>Gradient-Boosted Trees</a:t>
             </a:r>
             <a:pPr indent="0" marL="0">
               <a:buNone/>
@@ -4460,13 +5488,10 @@
             <a:r>
               <a:rPr lang="en-US" sz="1500" b="1" dirty="0">
                 <a:solidFill>
-                  <a:srgbClr val="000000"/>
-                </a:solidFill>
-                <a:highlight>
-                  <a:srgbClr val="FFFF00"/>
-                </a:highlight>
-              </a:rPr>
-              <a:t>[BEST_F1_VALUE]</a:t>
+                  <a:schemeClr val="tx1"/>
+                </a:solidFill>
+              </a:rPr>
+              <a:t>0.479</a:t>
             </a:r>
             <a:pPr indent="0" marL="0">
               <a:buNone/>
@@ -4502,13 +5527,10 @@
             <a:r>
               <a:rPr lang="en-US" sz="1500" b="1" dirty="0">
                 <a:solidFill>
-                  <a:srgbClr val="000000"/>
-                </a:solidFill>
-                <a:highlight>
-                  <a:srgbClr val="FFFF00"/>
-                </a:highlight>
-              </a:rPr>
-              <a:t>[FASTEST_MODEL]</a:t>
+                  <a:schemeClr val="tx1"/>
+                </a:solidFill>
+              </a:rPr>
+              <a:t>Logistic Regression</a:t>
             </a:r>
             <a:endParaRPr lang="en-US" sz="1500" dirty="0"/>
           </a:p>
@@ -4622,160 +5644,46 @@
           </a:p>
         </p:txBody>
       </p:sp>
-      <p:sp>
-        <p:nvSpPr>
-          <p:cNvPr id="3" name="ph-importance"/>
-          <p:cNvSpPr/>
-          <p:nvPr/>
-        </p:nvSpPr>
-        <p:spPr>
-          <a:xfrm>
-            <a:off x="548640" y="1280160"/>
-            <a:ext cx="5577840" cy="4572000"/>
-          </a:xfrm>
-          <a:prstGeom prst="roundRect">
-            <a:avLst>
-              <a:gd name="adj" fmla="val 1200"/>
-            </a:avLst>
-          </a:prstGeom>
-          <a:solidFill>
-            <a:srgbClr val="FFF8DB"/>
-          </a:solidFill>
-          <a:ln w="15875">
-            <a:solidFill>
-              <a:srgbClr val="EDA100"/>
-            </a:solidFill>
-            <a:prstDash val="dash"/>
-          </a:ln>
-        </p:spPr>
-      </p:sp>
-      <p:sp>
-        <p:nvSpPr>
-          <p:cNvPr id="4" name="Text 2"/>
-          <p:cNvSpPr txBox="1"/>
-          <p:nvPr/>
-        </p:nvSpPr>
-        <p:spPr>
-          <a:xfrm>
-            <a:off x="548640" y="1280160"/>
-            <a:ext cx="5577840" cy="4572000"/>
-          </a:xfrm>
-          <a:prstGeom prst="rect">
-            <a:avLst/>
-          </a:prstGeom>
-          <a:noFill/>
-          <a:ln/>
-        </p:spPr>
-        <p:txBody>
-          <a:bodyPr wrap="square" lIns="76200" tIns="76200" rIns="76200" bIns="76200" rtlCol="0" anchor="ctr"/>
-          <a:lstStyle/>
-          <a:p>
-            <a:pPr algn="ctr" indent="0" marL="0">
-              <a:buNone/>
-            </a:pPr>
-            <a:r>
-              <a:rPr lang="en-US" sz="1400" dirty="0">
-                <a:solidFill>
-                  <a:srgbClr val="7F6000"/>
-                </a:solidFill>
-              </a:rPr>
-              <a:t>Native chart: GBT top-8 feature importance</a:t>
-            </a:r>
-            <a:endParaRPr lang="en-US" sz="1400" dirty="0"/>
-          </a:p>
-          <a:p>
-            <a:pPr algn="ctr" indent="0" marL="0">
-              <a:buNone/>
-            </a:pPr>
-            <a:r>
-              <a:rPr lang="en-US" sz="1400" dirty="0">
-                <a:solidFill>
-                  <a:srgbClr val="7F6000"/>
-                </a:solidFill>
-              </a:rPr>
-              <a:t>(rebuild with notebook outputs: tables/feature_importance.csv)</a:t>
-            </a:r>
-            <a:endParaRPr lang="en-US" sz="1400" dirty="0"/>
-          </a:p>
-        </p:txBody>
-      </p:sp>
-      <p:sp>
-        <p:nvSpPr>
-          <p:cNvPr id="5" name="ph-temporal"/>
-          <p:cNvSpPr/>
-          <p:nvPr/>
-        </p:nvSpPr>
-        <p:spPr>
-          <a:xfrm>
-            <a:off x="6355080" y="1280160"/>
-            <a:ext cx="5285232" cy="4572000"/>
-          </a:xfrm>
-          <a:prstGeom prst="roundRect">
-            <a:avLst>
-              <a:gd name="adj" fmla="val 1200"/>
-            </a:avLst>
-          </a:prstGeom>
-          <a:solidFill>
-            <a:srgbClr val="FFF8DB"/>
-          </a:solidFill>
-          <a:ln w="15875">
-            <a:solidFill>
-              <a:srgbClr val="EDA100"/>
-            </a:solidFill>
-            <a:prstDash val="dash"/>
-          </a:ln>
-        </p:spPr>
-      </p:sp>
-      <p:sp>
-        <p:nvSpPr>
-          <p:cNvPr id="6" name="Text 4"/>
-          <p:cNvSpPr txBox="1"/>
-          <p:nvPr/>
-        </p:nvSpPr>
-        <p:spPr>
-          <a:xfrm>
-            <a:off x="6355080" y="1280160"/>
-            <a:ext cx="5285232" cy="4572000"/>
-          </a:xfrm>
-          <a:prstGeom prst="rect">
-            <a:avLst/>
-          </a:prstGeom>
-          <a:noFill/>
-          <a:ln/>
-        </p:spPr>
-        <p:txBody>
-          <a:bodyPr wrap="square" lIns="76200" tIns="76200" rIns="76200" bIns="76200" rtlCol="0" anchor="ctr"/>
-          <a:lstStyle/>
-          <a:p>
-            <a:pPr algn="ctr" indent="0" marL="0">
-              <a:buNone/>
-            </a:pPr>
-            <a:r>
-              <a:rPr lang="en-US" sz="1400" dirty="0">
-                <a:solidFill>
-                  <a:srgbClr val="7F6000"/>
-                </a:solidFill>
-              </a:rPr>
-              <a:t>Native chart: ROC-AUC random vs temporal split</a:t>
-            </a:r>
-            <a:endParaRPr lang="en-US" sz="1400" dirty="0"/>
-          </a:p>
-          <a:p>
-            <a:pPr algn="ctr" indent="0" marL="0">
-              <a:buNone/>
-            </a:pPr>
-            <a:r>
-              <a:rPr lang="en-US" sz="1400" dirty="0">
-                <a:solidFill>
-                  <a:srgbClr val="7F6000"/>
-                </a:solidFill>
-              </a:rPr>
-              <a:t>(rebuild with notebook outputs)</a:t>
-            </a:r>
-            <a:endParaRPr lang="en-US" sz="1400" dirty="0"/>
-          </a:p>
-        </p:txBody>
-      </p:sp>
+      <p:pic>
+        <p:nvPicPr>
+          <p:cNvPr id="3" name="fig-importance" descr="preencoded.png">    </p:cNvPr>
+          <p:cNvPicPr>
+            <a:picLocks noChangeAspect="1"/>
+          </p:cNvPicPr>
+          <p:nvPr/>
+        </p:nvPicPr>
+        <p:blipFill>
+          <a:blip r:embed="rId1"/>
+          <a:stretch>
+            <a:fillRect/>
+          </a:stretch>
+        </p:blipFill>
+        <p:spPr>
+          <a:xfrm>
+            <a:off x="548640" y="2131668"/>
+            <a:ext cx="5577840" cy="2868985"/>
+          </a:xfrm>
+          <a:prstGeom prst="rect">
+            <a:avLst/>
+          </a:prstGeom>
+        </p:spPr>
+      </p:pic>
+      <p:graphicFrame>
+        <p:nvGraphicFramePr>
+          <p:cNvPr id="4" name="chart-temporal" descr=""/>
+          <p:cNvGraphicFramePr/>
+          <p:nvPr/>
+        </p:nvGraphicFramePr>
+        <p:xfrm>
+          <a:off x="6355080" y="1280160"/>
+          <a:ext cx="5285232" cy="4572000"/>
+        </p:xfrm>
+        <a:graphic xmlns:a="http://schemas.openxmlformats.org/drawingml/2006/main">
+          <a:graphicData uri="http://schemas.openxmlformats.org/drawingml/2006/chart">
+            <c:chart xmlns:c="http://schemas.openxmlformats.org/drawingml/2006/chart" r:id="rId2"/>
+          </a:graphicData>
+        </a:graphic>
+      </p:graphicFrame>
       <p:sp>
         <p:nvSpPr>
           <p:cNvPr id="25" name="Slide Number Placeholder 0"/>
@@ -5034,13 +5942,10 @@
             <a:r>
               <a:rPr lang="en-US" sz="1500" dirty="0">
                 <a:solidFill>
-                  <a:srgbClr val="000000"/>
-                </a:solidFill>
-                <a:highlight>
-                  <a:srgbClr val="FFFF00"/>
-                </a:highlight>
-              </a:rPr>
-              <a:t>[BASELINE_ACCURACY]</a:t>
+                  <a:schemeClr val="accent6"/>
+                </a:solidFill>
+              </a:rPr>
+              <a:t>77.70%</a:t>
             </a:r>
             <a:pPr indent="0" marL="0">
               <a:buNone/>
@@ -5344,13 +6249,10 @@
             <a:r>
               <a:rPr lang="en-US" sz="1500" dirty="0">
                 <a:solidFill>
-                  <a:srgbClr val="000000"/>
-                </a:solidFill>
-                <a:highlight>
-                  <a:srgbClr val="FFFF00"/>
-                </a:highlight>
-              </a:rPr>
-              <a:t>[FASTEST_MODEL]</a:t>
+                  <a:schemeClr val="accent6"/>
+                </a:solidFill>
+              </a:rPr>
+              <a:t>Logistic Regression</a:t>
             </a:r>
             <a:pPr indent="0" marL="0">
               <a:buNone/>
@@ -5369,13 +6271,10 @@
             <a:r>
               <a:rPr lang="en-US" sz="1500" dirty="0">
                 <a:solidFill>
-                  <a:srgbClr val="000000"/>
-                </a:solidFill>
-                <a:highlight>
-                  <a:srgbClr val="FFFF00"/>
-                </a:highlight>
-              </a:rPr>
-              <a:t>[SLOWEST_MODEL]</a:t>
+                  <a:schemeClr val="accent6"/>
+                </a:solidFill>
+              </a:rPr>
+              <a:t>Random Forest</a:t>
             </a:r>
             <a:pPr indent="0" marL="0">
               <a:buNone/>
@@ -5639,13 +6538,10 @@
             <a:r>
               <a:rPr lang="en-US" sz="1900" dirty="0">
                 <a:solidFill>
-                  <a:srgbClr val="000000"/>
-                </a:solidFill>
-                <a:highlight>
-                  <a:srgbClr val="FFFF00"/>
-                </a:highlight>
-              </a:rPr>
-              <a:t>A leakage-free Spark pipeline over all [RAW_ROWS] 2025 flights</a:t>
+                  <a:srgbClr val="FFFFFF"/>
+                </a:solidFill>
+              </a:rPr>
+              <a:t>A leakage-free Spark pipeline over all 7,001,619 2025 flights</a:t>
             </a:r>
             <a:endParaRPr lang="en-US" sz="1900" dirty="0"/>
           </a:p>
@@ -5660,13 +6556,10 @@
             <a:r>
               <a:rPr lang="en-US" sz="1900" dirty="0">
                 <a:solidFill>
-                  <a:srgbClr val="000000"/>
-                </a:solidFill>
-                <a:highlight>
-                  <a:srgbClr val="FFFF00"/>
-                </a:highlight>
-              </a:rPr>
-              <a:t>[BEST_F1_MODEL] gave the best F1 ([BEST_F1_VALUE])</a:t>
+                  <a:srgbClr val="FFFFFF"/>
+                </a:solidFill>
+              </a:rPr>
+              <a:t>Gradient-Boosted Trees gave the best F1 (0.479)</a:t>
             </a:r>
             <a:endParaRPr lang="en-US" sz="1900" dirty="0"/>
           </a:p>
@@ -6727,13 +7620,10 @@
             <a:r>
               <a:rPr lang="en-US" sz="3600" b="1" dirty="0">
                 <a:solidFill>
-                  <a:srgbClr val="000000"/>
-                </a:solidFill>
-                <a:highlight>
-                  <a:srgbClr val="FFFF00"/>
-                </a:highlight>
-              </a:rPr>
-              <a:t>[RAW_ROWS]</a:t>
+                  <a:srgbClr val="1BAF7A"/>
+                </a:solidFill>
+              </a:rPr>
+              <a:t>7,001,619</a:t>
             </a:r>
             <a:endParaRPr lang="en-US" sz="3600" dirty="0"/>
           </a:p>
@@ -8454,13 +9344,10 @@
             <a:r>
               <a:rPr lang="en-US" sz="3000" b="1" dirty="0">
                 <a:solidFill>
-                  <a:srgbClr val="000000"/>
-                </a:solidFill>
-                <a:highlight>
-                  <a:srgbClr val="FFFF00"/>
-                </a:highlight>
-              </a:rPr>
-              <a:t>[RAW_ROWS]</a:t>
+                  <a:schemeClr val="accent1"/>
+                </a:solidFill>
+              </a:rPr>
+              <a:t>7,001,619</a:t>
             </a:r>
             <a:endParaRPr lang="en-US" sz="3000" dirty="0"/>
           </a:p>
@@ -8655,98 +9542,42 @@
             <a:r>
               <a:rPr lang="en-US" sz="1400" dirty="0">
                 <a:solidFill>
-                  <a:srgbClr val="000000"/>
-                </a:solidFill>
-                <a:highlight>
-                  <a:srgbClr val="FFFF00"/>
-                </a:highlight>
-              </a:rPr>
-              <a:t>[DELAY_RATE]</a:t>
+                  <a:schemeClr val="tx1"/>
+                </a:solidFill>
+              </a:rPr>
+              <a:t>22.31%</a:t>
             </a:r>
             <a:endParaRPr lang="en-US" sz="1400" dirty="0"/>
           </a:p>
         </p:txBody>
       </p:sp>
-      <p:sp>
-        <p:nvSpPr>
-          <p:cNvPr id="16" name="ph-hourly"/>
-          <p:cNvSpPr/>
-          <p:nvPr/>
-        </p:nvSpPr>
-        <p:spPr>
-          <a:xfrm>
-            <a:off x="6172200" y="1325880"/>
-            <a:ext cx="5486400" cy="4480560"/>
-          </a:xfrm>
-          <a:prstGeom prst="roundRect">
-            <a:avLst>
-              <a:gd name="adj" fmla="val 1224"/>
-            </a:avLst>
-          </a:prstGeom>
-          <a:solidFill>
-            <a:srgbClr val="FFF8DB"/>
-          </a:solidFill>
-          <a:ln w="15875">
-            <a:solidFill>
-              <a:srgbClr val="EDA100"/>
-            </a:solidFill>
-            <a:prstDash val="dash"/>
-          </a:ln>
-        </p:spPr>
-      </p:sp>
-      <p:sp>
-        <p:nvSpPr>
-          <p:cNvPr id="17" name="Text 15"/>
-          <p:cNvSpPr txBox="1"/>
-          <p:nvPr/>
-        </p:nvSpPr>
-        <p:spPr>
-          <a:xfrm>
-            <a:off x="6172200" y="1325880"/>
-            <a:ext cx="5486400" cy="4480560"/>
-          </a:xfrm>
-          <a:prstGeom prst="rect">
-            <a:avLst/>
-          </a:prstGeom>
-          <a:noFill/>
-          <a:ln/>
-        </p:spPr>
-        <p:txBody>
-          <a:bodyPr wrap="square" lIns="76200" tIns="76200" rIns="76200" bIns="76200" rtlCol="0" anchor="ctr"/>
-          <a:lstStyle/>
-          <a:p>
-            <a:pPr algn="ctr" indent="0" marL="0">
-              <a:buNone/>
-            </a:pPr>
-            <a:r>
-              <a:rPr lang="en-US" sz="1400" dirty="0">
-                <a:solidFill>
-                  <a:srgbClr val="7F6000"/>
-                </a:solidFill>
-              </a:rPr>
-              <a:t>Chart: delay rate by departure hour</a:t>
-            </a:r>
-            <a:endParaRPr lang="en-US" sz="1400" dirty="0"/>
-          </a:p>
-          <a:p>
-            <a:pPr algn="ctr" indent="0" marL="0">
-              <a:buNone/>
-            </a:pPr>
-            <a:r>
-              <a:rPr lang="en-US" sz="1400" dirty="0">
-                <a:solidFill>
-                  <a:srgbClr val="7F6000"/>
-                </a:solidFill>
-              </a:rPr>
-              <a:t>(rebuild with notebook outputs: tables/delay_rate_by_dep_hour.csv)</a:t>
-            </a:r>
-            <a:endParaRPr lang="en-US" sz="1400" dirty="0"/>
-          </a:p>
-        </p:txBody>
-      </p:sp>
-      <p:sp>
-        <p:nvSpPr>
-          <p:cNvPr id="18" name="Text 16"/>
+      <p:pic>
+        <p:nvPicPr>
+          <p:cNvPr id="16" name="fig-hourly" descr="preencoded.png">    </p:cNvPr>
+          <p:cNvPicPr>
+            <a:picLocks noChangeAspect="1"/>
+          </p:cNvPicPr>
+          <p:nvPr/>
+        </p:nvPicPr>
+        <p:blipFill>
+          <a:blip r:embed="rId1"/>
+          <a:stretch>
+            <a:fillRect/>
+          </a:stretch>
+        </p:blipFill>
+        <p:spPr>
+          <a:xfrm>
+            <a:off x="6172200" y="1830479"/>
+            <a:ext cx="5486400" cy="3471362"/>
+          </a:xfrm>
+          <a:prstGeom prst="rect">
+            <a:avLst/>
+          </a:prstGeom>
+        </p:spPr>
+      </p:pic>
+      <p:sp>
+        <p:nvSpPr>
+          <p:cNvPr id="17" name="Text 14"/>
           <p:cNvSpPr txBox="1"/>
           <p:nvPr/>
         </p:nvSpPr>
@@ -8942,7 +9773,7 @@
                   <a:schemeClr val="accent6"/>
                 </a:solidFill>
               </a:rPr>
-              <a:t>Google Colab · PySpark 4.0 · Spark SQL / DataFrames for processing · Spark MLlib for modelling</a:t>
+              <a:t>Google Colab · PySpark 4.0.4 · Spark SQL / DataFrames for processing · Spark MLlib for modelling</a:t>
             </a:r>
             <a:endParaRPr lang="en-US" sz="1400" dirty="0"/>
           </a:p>
@@ -9136,13 +9967,10 @@
             <a:r>
               <a:rPr lang="en-US" sz="3600" b="1" dirty="0">
                 <a:solidFill>
-                  <a:srgbClr val="000000"/>
-                </a:solidFill>
-                <a:highlight>
-                  <a:srgbClr val="FFFF00"/>
-                </a:highlight>
-              </a:rPr>
-              <a:t>[PARQUET_SPEEDUP]</a:t>
+                  <a:schemeClr val="accent3"/>
+                </a:solidFill>
+              </a:rPr>
+              <a:t>25.1x</a:t>
             </a:r>
             <a:endParaRPr lang="en-US" sz="3600" dirty="0"/>
           </a:p>
@@ -9240,13 +10068,10 @@
             <a:r>
               <a:rPr lang="en-US" sz="3600" b="1" dirty="0">
                 <a:solidFill>
-                  <a:srgbClr val="000000"/>
-                </a:solidFill>
-                <a:highlight>
-                  <a:srgbClr val="FFFF00"/>
-                </a:highlight>
-              </a:rPr>
-              <a:t>[SCALE_LR_SPEEDUP]</a:t>
+                  <a:schemeClr val="accent1"/>
+                </a:solidFill>
+              </a:rPr>
+              <a:t>2.41x</a:t>
             </a:r>
             <a:endParaRPr lang="en-US" sz="3600" dirty="0"/>
           </a:p>
@@ -9282,7 +10107,7 @@
                   <a:schemeClr val="accent6"/>
                 </a:solidFill>
               </a:rPr>
-              <a:t>LR training speed-up, 1 → </a:t>
+              <a:t>faster full scan, 1 → </a:t>
             </a:r>
             <a:pPr indent="0" marL="0">
               <a:buNone/>
@@ -9290,13 +10115,10 @@
             <a:r>
               <a:rPr lang="en-US" sz="1300" dirty="0">
                 <a:solidFill>
-                  <a:srgbClr val="000000"/>
-                </a:solidFill>
-                <a:highlight>
-                  <a:srgbClr val="FFFF00"/>
-                </a:highlight>
-              </a:rPr>
-              <a:t>[SCALE_MAX_CORES]</a:t>
+                  <a:schemeClr val="accent6"/>
+                </a:solidFill>
+              </a:rPr>
+              <a:t>2</a:t>
             </a:r>
             <a:pPr indent="0" marL="0">
               <a:buNone/>
@@ -9551,139 +10373,22 @@
           </a:p>
         </p:txBody>
       </p:sp>
-      <p:sp>
-        <p:nvSpPr>
-          <p:cNvPr id="3" name="Text 1"/>
-          <p:cNvSpPr txBox="1"/>
-          <p:nvPr/>
-        </p:nvSpPr>
-        <p:spPr>
-          <a:xfrm>
-            <a:off x="548640" y="1463040"/>
-            <a:ext cx="5486400" cy="4206240"/>
-          </a:xfrm>
-          <a:prstGeom prst="rect">
-            <a:avLst/>
-          </a:prstGeom>
-          <a:noFill/>
-          <a:ln/>
-        </p:spPr>
-        <p:txBody>
-          <a:bodyPr wrap="square" lIns="0" tIns="0" rIns="0" bIns="0" rtlCol="0" anchor="t"/>
-          <a:lstStyle/>
-          <a:p>
-            <a:pPr marL="203200" indent="-203200">
-              <a:spcAft>
-                <a:spcPts val="600"/>
-              </a:spcAft>
-              <a:buSzPct val="100000"/>
-              <a:buChar char="•"/>
-            </a:pPr>
-            <a:r>
-              <a:rPr lang="en-US" sz="1700" dirty="0">
-                <a:solidFill>
-                  <a:schemeClr val="tx1"/>
-                </a:solidFill>
-              </a:rPr>
-              <a:t>Remove cancelled flights</a:t>
-            </a:r>
-            <a:endParaRPr lang="en-US" sz="1700" dirty="0"/>
-          </a:p>
-          <a:p>
-            <a:pPr marL="203200" indent="-203200">
-              <a:spcAft>
-                <a:spcPts val="600"/>
-              </a:spcAft>
-              <a:buSzPct val="100000"/>
-              <a:buChar char="•"/>
-            </a:pPr>
-            <a:r>
-              <a:rPr lang="en-US" sz="1700" dirty="0">
-                <a:solidFill>
-                  <a:schemeClr val="tx1"/>
-                </a:solidFill>
-              </a:rPr>
-              <a:t>Remove diverted flights</a:t>
-            </a:r>
-            <a:endParaRPr lang="en-US" sz="1700" dirty="0"/>
-          </a:p>
-          <a:p>
-            <a:pPr marL="203200" indent="-203200">
-              <a:spcAft>
-                <a:spcPts val="600"/>
-              </a:spcAft>
-              <a:buSzPct val="100000"/>
-              <a:buChar char="•"/>
-            </a:pPr>
-            <a:r>
-              <a:rPr lang="en-US" sz="1700" dirty="0">
-                <a:solidFill>
-                  <a:schemeClr val="tx1"/>
-                </a:solidFill>
-              </a:rPr>
-              <a:t>Remove rows with null ARR_DELAY</a:t>
-            </a:r>
-            <a:endParaRPr lang="en-US" sz="1700" dirty="0"/>
-          </a:p>
-          <a:p>
-            <a:pPr marL="203200" indent="-203200">
-              <a:spcAft>
-                <a:spcPts val="600"/>
-              </a:spcAft>
-              <a:buSzPct val="100000"/>
-              <a:buChar char="•"/>
-            </a:pPr>
-            <a:r>
-              <a:rPr lang="en-US" sz="1700" dirty="0">
-                <a:solidFill>
-                  <a:schemeClr val="tx1"/>
-                </a:solidFill>
-              </a:rPr>
-              <a:t>Remove duplicate records</a:t>
-            </a:r>
-            <a:endParaRPr lang="en-US" sz="1700" dirty="0"/>
-          </a:p>
-          <a:p>
-            <a:pPr marL="203200" indent="-203200">
-              <a:spcAft>
-                <a:spcPts val="600"/>
-              </a:spcAft>
-              <a:buSzPct val="100000"/>
-              <a:buChar char="•"/>
-            </a:pPr>
-            <a:r>
-              <a:rPr lang="en-US" sz="1700" dirty="0">
-                <a:solidFill>
-                  <a:schemeClr val="tx1"/>
-                </a:solidFill>
-              </a:rPr>
-              <a:t>Remove impossible schedule values</a:t>
-            </a:r>
-            <a:endParaRPr lang="en-US" sz="1700" dirty="0"/>
-          </a:p>
-          <a:p>
-            <a:pPr marL="203200" indent="-203200">
-              <a:spcAft>
-                <a:spcPts val="600"/>
-              </a:spcAft>
-              <a:buSzPct val="100000"/>
-              <a:buChar char="•"/>
-            </a:pPr>
-            <a:r>
-              <a:rPr lang="en-US" sz="1700" dirty="0">
-                <a:solidFill>
-                  <a:srgbClr val="000000"/>
-                </a:solidFill>
-                <a:highlight>
-                  <a:srgbClr val="FFFF00"/>
-                </a:highlight>
-              </a:rPr>
-              <a:t>Rows: [FUNNEL_0_ROWS] → [FUNNEL_5_ROWS]</a:t>
-            </a:r>
-            <a:endParaRPr lang="en-US" sz="1700" dirty="0"/>
-          </a:p>
-        </p:txBody>
-      </p:sp>
+      <p:graphicFrame>
+        <p:nvGraphicFramePr>
+          <p:cNvPr id="3" name="chart-funnel" descr=""/>
+          <p:cNvGraphicFramePr/>
+          <p:nvPr/>
+        </p:nvGraphicFramePr>
+        <p:xfrm>
+          <a:off x="548640" y="1280160"/>
+          <a:ext cx="5577840" cy="4480560"/>
+        </p:xfrm>
+        <a:graphic xmlns:a="http://schemas.openxmlformats.org/drawingml/2006/main">
+          <a:graphicData uri="http://schemas.openxmlformats.org/drawingml/2006/chart">
+            <c:chart xmlns:c="http://schemas.openxmlformats.org/drawingml/2006/chart" r:id="rId1"/>
+          </a:graphicData>
+        </a:graphic>
+      </p:graphicFrame>
       <p:sp>
         <p:nvSpPr>
           <p:cNvPr id="4" name="leak-card"/>
@@ -9745,7 +10450,7 @@
           <p:nvPr/>
         </p:nvPicPr>
         <p:blipFill>
-          <a:blip r:embed="rId1"/>
+          <a:blip r:embed="rId2"/>
           <a:stretch>
             <a:fillRect/>
           </a:stretch>
@@ -9762,7 +10467,7 @@
       </p:pic>
       <p:sp>
         <p:nvSpPr>
-          <p:cNvPr id="7" name="Text 4"/>
+          <p:cNvPr id="7" name="Text 3"/>
           <p:cNvSpPr txBox="1"/>
           <p:nvPr/>
         </p:nvSpPr>
@@ -9798,7 +10503,7 @@
       </p:sp>
       <p:sp>
         <p:nvSpPr>
-          <p:cNvPr id="8" name="Text 5"/>
+          <p:cNvPr id="8" name="Text 4"/>
           <p:cNvSpPr txBox="1"/>
           <p:nvPr/>
         </p:nvSpPr>
@@ -10018,13 +10723,10 @@
             <a:r>
               <a:rPr lang="en-US" sz="3200" b="1" dirty="0">
                 <a:solidFill>
-                  <a:srgbClr val="000000"/>
-                </a:solidFill>
-                <a:highlight>
-                  <a:srgbClr val="FFFF00"/>
-                </a:highlight>
-              </a:rPr>
-              <a:t>[N_FEATURES]</a:t>
+                  <a:schemeClr val="tx1"/>
+                </a:solidFill>
+              </a:rPr>
+              <a:t>39</a:t>
             </a:r>
             <a:pPr algn="l" indent="0" marL="0">
               <a:buNone/>
@@ -10993,7 +11695,7 @@
                   <a:schemeClr val="accent6"/>
                 </a:solidFill>
               </a:rPr>
-              <a:t>Gradient summed across partitions: scales almost linearly</a:t>
+              <a:t>Gradients computed per partition: scales once each task has enough data</a:t>
             </a:r>
             <a:endParaRPr lang="en-US" sz="1300" dirty="0"/>
           </a:p>

</xml_diff>

<commit_message>
Deck: full recording script for a pre-recorded talk
Speaker notes rewritten as a ~1,290-word script (~9.5-10 min) with
timings derived from word count; Q&A prep removed and its answers worked
into the narration; end slide reads 'Thank you'.

Co-Authored-By: Claude Opus 5.5 <noreply@anthropic.com>
Claude-Session: https://claude.ai/code/session_013cmZjtFTpWtFMxYtK982h3
</commit_message>
<xml_diff>
--- a/bdmla-flight-delay/presentation/BDMLA_CW1_Flight_Delay_Presentation.pptx
+++ b/bdmla-flight-delay/presentation/BDMLA_CW1_Flight_Delay_Presentation.pptx
@@ -1761,7 +1761,7 @@
           <a:lstStyle/>
           <a:p>
             <a:r>
-              <a:t>[0:00-0:20] Good morning. My project asks a simple, practical question: can we tell, before a plane leaves the gate, whether it will arrive late? I used Apache Spark on every U.S. domestic flight from 2025, 7,001,619 of them, and compared three machine learning models.</a:t>
+              <a:t>[0:00-0:24]  Hello, my name is [your name], and this is my Big Data and Machine Learning Applications project: predicting airline flight delays with Apache Spark. I used every U.S. domestic flight from 2025, 7,001,619 of them, to test one practical question: can we tell, before a plane even leaves the gate, that it is going to arrive late?</a:t>
             </a:r>
           </a:p>
         </p:txBody>
@@ -1831,7 +1831,7 @@
           <a:lstStyle/>
           <a:p>
             <a:r>
-              <a:t>[4:40-5:20] Four groups of features, all known in advance: calendar and time, including distance to a public holiday; basic flight details; congestion, meaning how many flights are scheduled at the same airport in the same hour; and aircraft rotation, built with a Spark window function over each tail number. Airports and routes have thousands of values, so I replaced them with their historical delay rate, fitted on the training data only.</a:t>
+              <a:t>[4:51-5:31]  I ended up with 39 features in four groups, all known in advance: calendar and time, including how close the date is to a public holiday; basic flight details; airport congestion, meaning how many flights are scheduled at the same airport in the same hour; and aircraft rotation, built with a Spark window function over each tail number. Airports and routes have thousands of values, which would explode the feature space and break Spark's tree limits, so I replaced each with its smoothed historical delay rate, fitted on the training data only.</a:t>
             </a:r>
           </a:p>
         </p:txBody>
@@ -1901,7 +1901,7 @@
           <a:lstStyle/>
           <a:p>
             <a:r>
-              <a:t>[5:20-6:00] The training pipeline: a random 70/10/20 split, target encoding fitted on training data only, then the features are assembled and standardised. Because only about one flight in five is delayed, every model gets class weights. Each model is tuned with 3-fold cross-validation on PR-AUC, the decision threshold is chosen on the validation set, and the test set is touched once at the end, plus a stricter temporal test I'll show shortly.</a:t>
+              <a:t>[5:31-6:10]  Here is the training pipeline. The data is split 70, 10 and 20 percent into train, validation and test sets. Because Colab only has two cores, models were trained on a 30% sample of the training set, but validation and test were always scored in full. Every model gets class weights, so delayed flights count as much as on-time ones. Each model is tuned with three-fold cross-validation on PR-AUC, the decision threshold is chosen on the validation set, and the test set is used only once, at the end.</a:t>
             </a:r>
           </a:p>
         </p:txBody>
@@ -1971,7 +1971,7 @@
           <a:lstStyle/>
           <a:p>
             <a:r>
-              <a:t>[6:00-6:55] These are the test results. Gradient-boosted trees had the best F1, 0.479, and the best ROC-AUC, 0.735. Look at the last row: a 'model' that always says on time gets 77.70% accuracy and catches zero delays. That's why accuracy alone is misleading here, and why I focus on recall, F1 and PR-AUC. Both tree models clearly beat logistic regression, so the non-linear interactions matter. And boosting wins twice: more accurate than the tuned random forest, and less than a quarter of the training time.</a:t>
+              <a:t>[6:10-6:51]  These are the test results. Gradient-Boosted Trees came out best, with an F1 of 0.479 and a ROC-AUC of 0.735. Notice the last row of the table: a 'model' that always says on time gets 77.70% accuracy and catches zero delays. That's why accuracy on its own is misleading here, and why I focus on recall, F1 and PR-AUC instead. Both tree models clearly beat Logistic Regression, so the non-linear interactions matter. Tuning improved Random Forest, but doubled its training time, and boosting still beat it while training in less than a quarter of the time.</a:t>
             </a:r>
           </a:p>
         </p:txBody>
@@ -2041,7 +2041,7 @@
           <a:lstStyle/>
           <a:p>
             <a:r>
-              <a:t>[6:55-7:50] On the left, permutation importance: how much accuracy drops when one feature is shuffled. The two that matter most are the historical delay rate of that airport at that hour, and the scheduled turnaround time, which is the delay-propagation story again. On the right is the stricter test: train on January to September and predict October to December. ROC-AUC drops from 0.735 to 0.679 for boosting, and logistic regression collapses because it never saw those months. A random split lets the model learn specific storm days; the temporal number is the honest one for real use.</a:t>
+              <a:t>[6:51-7:35]  What is the model actually using? The left chart shows permutation importance: how much accuracy drops when one feature is shuffled. The two that matter most are the historical delay rate of that airport at that hour, and the scheduled turnaround time, which is the delay-propagation story again. On the right is my strictest test: train on January to September, then predict October to December. ROC-AUC drops from 0.735 to 0.679 for boosting. A random split lets the model learn specific storm days that also appear in the test set, so this temporal figure is the honest estimate for real use.</a:t>
             </a:r>
           </a:p>
         </p:txBody>
@@ -2111,7 +2111,7 @@
           <a:lstStyle/>
           <a:p>
             <a:r>
-              <a:t>[7:50-8:30] A few real challenges. Colab disconnected my first full run after more than three hours, so I added checkpoints and a resume option. On Colab's Spark 4, the feature-importance labels were silently shifted; I only caught it because logistic regression claimed day-of-week was the strongest feature, which made no sense. Plus leakage, imbalance, and fitting 3 gigabytes into a 12 gigabyte machine.</a:t>
+              <a:t>[7:35-8:14]  The project had some real challenges. My first full run was disconnected by Colab after more than three hours, so I added Parquet checkpoints, saved results after every model, and a resume option that reuses the tuned settings. On Colab's Spark 4, the feature-importance labels were silently shifted; I only caught it because Logistic Regression claimed day-of-week was its strongest feature, which made no sense. I fixed it and added an assertion. And throughout, I had to control leakage, handle the imbalance, and fit three gigabytes into a twelve-gigabyte machine.</a:t>
             </a:r>
           </a:p>
         </p:txBody>
@@ -2181,7 +2181,7 @@
           <a:lstStyle/>
           <a:p>
             <a:r>
-              <a:t>[8:30-9:00] Next steps: weather forecasts are the biggest missing signal; XGBoost on GPUs; the full training set on a real Dataproc cluster; and Spark streaming to update predictions on the day as earlier flights report delays.</a:t>
+              <a:t>[8:14-8:42]  For future work, weather forecasts are the biggest missing signal, so joining NOAA data would come first. I'd also try XGBoost or LightGBM on Spark with GPU acceleration, train on the full data on a real Dataproc cluster, where the same code simply runs on more executors, and use Spark Structured Streaming to update predictions on the day as earlier flights report delays.</a:t>
             </a:r>
           </a:p>
         </p:txBody>
@@ -2251,7 +2251,7 @@
           <a:lstStyle/>
           <a:p>
             <a:r>
-              <a:t>[9:00-9:40] To wrap up: a full, leakage-free Spark pipeline over every 2025 domestic flight. Gradient-boosted trees performed best. The biggest lessons were about evaluation, not algorithms: handling imbalance, choosing the threshold, and testing on future months. And schedule-only prediction has a ceiling, so weather data and on-the-day updates are where the next gains are.</a:t>
+              <a:t>[8:42-9:11]  To conclude: I built a complete, leakage-free Spark pipeline over every U.S. domestic flight in 2025, and Gradient-Boosted Trees performed best. The biggest lessons were about evaluation rather than algorithms: handling the imbalance, choosing the threshold for the business need, and testing honestly on future months. Schedule-only prediction works, but it has a ceiling, so weather data and on-the-day updates are where the next gains will come from.</a:t>
             </a:r>
           </a:p>
         </p:txBody>
@@ -2321,54 +2321,7 @@
           <a:lstStyle/>
           <a:p>
             <a:r>
-              <a:t>[9:40-10:00] Thank you, I'm happy to take questions.</a:t>
-            </a:r>
-          </a:p>
-          <a:p/>
-          <a:p>
-            <a:r>
-              <a:t>LIKELY QUESTIONS (prepare, don't read):</a:t>
-            </a:r>
-          </a:p>
-          <a:p>
-            <a:r>
-              <a:t>- Why not use departure delay? It's only known after the plane leaves, so the model would be useless for planning, and it inflates accuracy (leakage).</a:t>
-            </a:r>
-          </a:p>
-          <a:p>
-            <a:r>
-              <a:t>- Why is accuracy not enough? Always predicting "on time" already gets 77.70%; we care about catching delays (recall) without too many false alarms (precision).</a:t>
-            </a:r>
-          </a:p>
-          <a:p>
-            <a:r>
-              <a:t>- Why target encoding? Hundreds of airports and thousands of routes; one-hot would explode the feature space, and Spark trees need maxBins &gt;= categories. Fitted on training data only.</a:t>
-            </a:r>
-          </a:p>
-          <a:p>
-            <a:r>
-              <a:t>- Why did you sample the training data? Colab has 2 cores and ~12 GB RAM; validation and test were always scored in full. On a cluster I'd use everything.</a:t>
-            </a:r>
-          </a:p>
-          <a:p>
-            <a:r>
-              <a:t>- How would this scale? Same code, different master URL; LR and RF parallelise well, GBT is sequential across rounds. GPUs via RAPIDS or XGBoost-Spark. A full scan was 2.41x faster on 2 cores than 1.</a:t>
-            </a:r>
-          </a:p>
-          <a:p>
-            <a:r>
-              <a:t>- Could tail numbers leak? Slightly: aircraft can be swapped on the day. In production you'd use the planned rotation from the airline.</a:t>
-            </a:r>
-          </a:p>
-          <a:p>
-            <a:r>
-              <a:t>- Why the temporal drop? The random split lets the model learn specific bad days; Oct-Dec months were never seen in training.</a:t>
-            </a:r>
-          </a:p>
-          <a:p/>
-          <a:p>
-            <a:r>
-              <a:t>Key references: Ball et al. (2010); Bureau of Transportation Statistics (2026); Kaufman et al. (2012); Meng et al. (2016); Saito &amp; Rehmsmeier (2015); Zaharia et al. (2016).</a:t>
+              <a:t>[9:11-9:19]  Thank you very much for watching. The full code, results and report are included in my submission.</a:t>
             </a:r>
           </a:p>
         </p:txBody>
@@ -2438,7 +2391,7 @@
           <a:lstStyle/>
           <a:p>
             <a:r>
-              <a:t>[0:20-0:55] Delays are expensive: a U.S. study put the cost at around 33 billion dollars in 2007 alone. The industry rule is simple: 15 minutes or more late counts as delayed. BTS publishes a record for every domestic flight, which gives millions of labelled examples. If we can flag risky flights early, airlines can re-plan crews and aircraft, and passengers with tight connections can be warned.</a:t>
+              <a:t>[0:24-1:03]  Delays matter because they are expensive. A major U.S. study estimated the cost at around 33 billion dollars in 2007 alone, shared between airlines, passengers and lost demand. The industry uses a simple rule: a flight that arrives 15 minutes or more after schedule counts as delayed. The Bureau of Transportation Statistics publishes a record for every domestic flight, which gives us millions of labelled examples. If risky flights can be flagged early, airlines can re-plan crews and spare aircraft, and passengers with tight connections can be warned.</a:t>
             </a:r>
           </a:p>
         </p:txBody>
@@ -2508,7 +2461,7 @@
           <a:lstStyle/>
           <a:p>
             <a:r>
-              <a:t>[0:55-1:25] So the question is: using only what is known before departure, will this flight be 15 or more minutes late? That 'before departure' part matters. Many online examples use departure delay as an input, which is basically cheating, because you only know it once the plane has gone. My approach: Spark for the whole year of data, schedule-based features, and three MLlib classifiers compared fairly.</a:t>
+              <a:t>[1:03-1:41]  So the problem statement is: using only information known before departure, will this flight arrive 15 or more minutes late? That makes it a binary classification problem. The 'before departure' condition is the important part. Many online examples use the departure delay as an input, but you only know that once the plane has left, so the model looks accurate but is useless in practice. My approach is to process the whole year with Spark, build features from the schedule only, and compare three Spark MLlib classifiers fairly.</a:t>
             </a:r>
           </a:p>
         </p:txBody>
@@ -2578,7 +2531,7 @@
           <a:lstStyle/>
           <a:p>
             <a:r>
-              <a:t>[1:25-1:50] Five objectives: ingest and clean everything in Spark, keep the features leakage-free, train three MLlib models, evaluate them properly for an imbalanced problem, and show how it scales. The scope is all 2025 U.S. domestic flights, schedule information only, run on a free Colab machine.</a:t>
+              <a:t>[1:41-2:09]  I set five objectives: ingest and clean all twelve monthly files in Spark; engineer features with no target leakage; train Logistic Regression, Random Forest and Gradient-Boosted Trees; evaluate them with metrics that suit an imbalanced problem, plus training time; and show how the pipeline scales out. The scope is all 2025 U.S. domestic flights, using schedule information only, running on a free Google Colab machine.</a:t>
             </a:r>
           </a:p>
         </p:txBody>
@@ -2648,7 +2601,7 @@
           <a:lstStyle/>
           <a:p>
             <a:r>
-              <a:t>[1:50-2:25] The data is the official BTS on-time table: twelve monthly files, 3.17 gigabytes, 7,001,619 flights. Each file has about 110 columns but I only load 17, which I'll explain under leakage. After cleaning, 22.31% of flights are delayed, so the classes are imbalanced: a model that always says 'on time' already gets 77.70% accuracy. Converting the CSVs to Parquet once made the same query 25.1x faster.</a:t>
+              <a:t>[2:09-2:44]  The data is the official BTS on-time performance table: twelve monthly CSV files, 3.17 gigabytes, and 7,001,619 flights. Each file has about 110 columns, but I only load 17 of them, for leakage reasons I'll come back to. After cleaning, 22.31% of flights are delayed. So the classes are imbalanced: a model that always says 'on time' would already score 77.70% accuracy. One early optimisation was converting the CSVs to Parquet once; after that, the same query ran 25.1x faster.</a:t>
             </a:r>
           </a:p>
         </p:txBody>
@@ -2718,7 +2671,7 @@
           <a:lstStyle/>
           <a:p>
             <a:r>
-              <a:t>[2:25-3:05] Two patterns shaped my features. On the left: only about 9 percent of 5am departures arrive late, but by 7pm it's about a third. On the right: the later the leg of the day for an aircraft, and the tighter its scheduled turnaround, the more likely it is to be late. Delays roll forward through an aircraft's day, so I built features that capture exactly that.</a:t>
+              <a:t>[2:44-3:21]  Exploring the data showed two patterns that shaped my features. On the left, the delay rate by scheduled departure hour: only about 9 percent of 5am departures arrive late, but by 7pm it's around a third. On the right, the later the leg of the day for an aircraft, the more likely it is to be late, and very tight turnarounds under 40 minutes have a 38 percent delay rate. Delays roll forward through an aircraft's day, so I built features that capture exactly that.</a:t>
             </a:r>
           </a:p>
         </p:txBody>
@@ -2788,7 +2741,7 @@
           <a:lstStyle/>
           <a:p>
             <a:r>
-              <a:t>[3:05-3:40] Here is the whole pipeline. The twelve files sit in Google Drive. Spark reads each month, maps the column names, keeps only the allowed columns and unions them. Everything is written once to Parquet, then schedule features, cleaning and the label. The second row is the machine learning part: split, encode, train, tune, evaluate, and export everything for the report.</a:t>
+              <a:t>[3:21-3:54]  This is the whole pipeline. The twelve files sit in Google Drive. Spark reads each month, maps the column names, keeps only the allowed columns and unions them into one DataFrame. That is written once to Parquet, which also acts as a checkpoint. Then come the schedule features, cleaning and the label. The second row is the machine learning layer: split, encode, train, tune and evaluate, and finally export every chart and table used in my report.</a:t>
             </a:r>
           </a:p>
         </p:txBody>
@@ -2858,7 +2811,7 @@
           <a:lstStyle/>
           <a:p>
             <a:r>
-              <a:t>[3:40-3:55] The stack: Spark through PySpark, with MLlib for the models and Spark SQL plus Parquet for the data work, Python for plotting, all running on Google Colab with the data and checkpoints in Google Drive.</a:t>
+              <a:t>[3:54-4:11]  The technology stack is Apache Spark through PySpark, with MLlib for the models and Spark SQL with Parquet for the data processing, Python for plotting, and Google Colab for compute, with the data and checkpoints stored in Google Drive.</a:t>
             </a:r>
           </a:p>
         </p:txBody>
@@ -2928,7 +2881,7 @@
           <a:lstStyle/>
           <a:p>
             <a:r>
-              <a:t>[3:55-4:40] Cleaning followed the brief: remove cancelled and diverted flights and rows without an arrival delay, then duplicates and impossible values, leaving 6,879,483 flights. The bigger issue is leakage. Columns like wheels-on time or the delay-cause minutes are only known after landing, so they're never loaded. I also excluded departure delay and taxi-out. One subtle point: if you count flights per hour after removing cancellations, a stormy day looks quiet and the feature leaks the outcome, so those counts are computed on the full schedule first.</a:t>
+              <a:t>[4:11-4:51]  Cleaning followed the brief: remove cancelled and diverted flights and rows with no arrival delay, then duplicates and impossible values, which leaves 6,879,483 flights. The bigger issue is leakage. Columns such as wheels-on time or the delay-cause minutes are only known after landing, so they are never loaded. I also excluded departure delay and taxi-out time. There's a subtle trap too: if you count flights per hour after removing cancellations, a stormy day looks quiet, and the feature leaks the outcome. So those counts are calculated on the full schedule first.</a:t>
             </a:r>
           </a:p>
         </p:txBody>
@@ -14711,7 +14664,7 @@
           <a:lstStyle/>
           <a:p>
             <a:r>
-              <a:t>Thank you. Questions?</a:t>
+              <a:t>Thank you</a:t>
             </a:r>
           </a:p>
         </p:txBody>

</xml_diff>

<commit_message>
Merge useful points from the ChatGPT review versions
Name on title page/slide/script, historical-cost caveat, cautious
explanation of the Logistic Regression temporal collapse, 'importance is
not causation', and validate-before-extending future work. Notes and
slides stay consistent (checked for withdrawn claims).

Co-Authored-By: Claude Opus 5.5 <noreply@anthropic.com>
Claude-Session: https://claude.ai/code/session_013cmZjtFTpWtFMxYtK982h3
</commit_message>
<xml_diff>
--- a/bdmla-flight-delay/presentation/BDMLA_CW1_Flight_Delay_Presentation.pptx
+++ b/bdmla-flight-delay/presentation/BDMLA_CW1_Flight_Delay_Presentation.pptx
@@ -1503,7 +1503,7 @@
           <a:lstStyle/>
           <a:p>
             <a:r>
-              <a:t>[0:00-0:24]  Hello, my name is [your name], and this is my Big Data and Machine Learning Applications project: predicting airline flight delays with Apache Spark. I used every U.S. domestic flight from 2025, 7,001,619 of them, to test one practical question: can we tell, before a plane even leaves the gate, that it is going to arrive late?</a:t>
+              <a:t>[0:00-0:24]  Hello, my name is Kelvin Soh, and this is my Big Data and Machine Learning Applications project: predicting airline flight delays with Apache Spark. I used every U.S. domestic flight from 2025, 7,001,619 of them, to test one practical question: can we tell, before a plane even leaves the gate, that it is going to arrive late?</a:t>
             </a:r>
           </a:p>
         </p:txBody>
@@ -2063,7 +2063,7 @@
           <a:lstStyle/>
           <a:p>
             <a:r>
-              <a:t>[8:59-9:22]  To conclude: I built a Spark pipeline over every U.S. domestic flight in 2025 that excludes post-flight information. On the random split, Gradient-Boosted Trees performed best; on later months, Random Forest had the higher F1. Schedule-only prediction works, but it has a ceiling, and weather data and cleaner validation are the natural next steps.</a:t>
+              <a:t>[8:59-9:26]  To conclude: I built a Spark pipeline over every U.S. domestic flight in 2025 that excludes post-flight information. On the random split, Gradient-Boosted Trees performed best; on later months, Random Forest had the higher F1. Schedule-only prediction works, but it has a ceiling, and before extending it I would first validate the method itself: the rotation features, the encoding and the chronological validation.</a:t>
             </a:r>
           </a:p>
         </p:txBody>
@@ -2133,7 +2133,7 @@
           <a:lstStyle/>
           <a:p>
             <a:r>
-              <a:t>[9:22-9:26]  The main references I used are listed here.</a:t>
+              <a:t>[9:26-9:30]  The main references I used are listed here.</a:t>
             </a:r>
           </a:p>
         </p:txBody>
@@ -2203,7 +2203,7 @@
           <a:lstStyle/>
           <a:p>
             <a:r>
-              <a:t>[9:26-9:33]  Thank you very much for watching. The full code, results and report are included in my submission.</a:t>
+              <a:t>[9:30-9:37]  Thank you very much for watching. The full code, results and report are included in my submission.</a:t>
             </a:r>
           </a:p>
         </p:txBody>
@@ -10068,7 +10068,7 @@
           <a:lstStyle/>
           <a:p>
             <a:r>
-              <a:t>[Your name]  ·  [Student ID]  ·  M33877  ·  November 2026</a:t>
+              <a:t>Kelvin Soh  ·  Student ID: [Student ID]  ·  M33877  ·  November 2026</a:t>
             </a:r>
           </a:p>
         </p:txBody>
@@ -15816,7 +15816,7 @@
                   <a:srgbClr val="1F1F1F"/>
                 </a:solidFill>
               </a:rPr>
-              <a:t>Schedule-only prediction is possible but limited; weather data and cleaner validation are the next steps.</a:t>
+              <a:t>Before extending the model: audit the rotation features, use out-of-fold encoding and chronological validation.</a:t>
             </a:r>
           </a:p>
         </p:txBody>

</xml_diff>

<commit_message>
Add Gamma-formatted deck v4 (logo and slide 17 fixes); fill in name and student ID
Co-Authored-By: Claude Opus 5.5 <noreply@anthropic.com>
Claude-Session: https://claude.ai/code/session_013cmZjtFTpWtFMxYtK982h3
</commit_message>
<xml_diff>
--- a/bdmla-flight-delay/presentation/BDMLA_CW1_Flight_Delay_Presentation.pptx
+++ b/bdmla-flight-delay/presentation/BDMLA_CW1_Flight_Delay_Presentation.pptx
@@ -1507,7 +1507,7 @@
           <a:lstStyle/>
           <a:p>
             <a:r>
-              <a:t>[0:00-0:24]  Hello, my name is Kelvin Soh, and this is my Big Data and Machine Learning Applications project: predicting airline flight delays with Apache Spark. I used every U.S. domestic flight from 2025, 7,001,619 of them, to test one practical question: can we tell, before a plane even leaves the gate, that it is going to arrive late?</a:t>
+              <a:t>[0:00-0:25]  Hello, my name is Soh Chee Yong, and this is my Big Data and Machine Learning Applications project: predicting airline flight delays with Apache Spark. I used every U.S. domestic flight from 2025, 7,001,619 of them, to test one practical question: can we tell, before a plane even leaves the gate, that it is going to arrive late?</a:t>
             </a:r>
           </a:p>
         </p:txBody>
@@ -1577,7 +1577,7 @@
           <a:lstStyle/>
           <a:p>
             <a:r>
-              <a:t>[4:34-4:41]  The stack: Spark through PySpark, MLlib, Spark SQL with Parquet, Python, and Google Colab with Google Drive.</a:t>
+              <a:t>[4:34-4:42]  The stack: Spark through PySpark, MLlib, Spark SQL with Parquet, Python, and Google Colab with Google Drive.</a:t>
             </a:r>
           </a:p>
         </p:txBody>
@@ -1647,7 +1647,7 @@
           <a:lstStyle/>
           <a:p>
             <a:r>
-              <a:t>[4:41-5:21]  Cleaning followed the brief: remove cancelled and diverted flights and rows with no arrival delay, then duplicates and impossible values, which leaves 6,879,483 flights. The bigger issue is leakage. Columns such as wheels-on time or the delay-cause minutes are only known after landing, so they are never loaded. I also excluded departure delay and taxi-out time. There's a subtle trap too: if you count flights per hour after removing cancellations, a stormy day looks quiet, and the feature leaks the outcome. So those counts are calculated on the full schedule first.</a:t>
+              <a:t>[4:42-5:21]  Cleaning followed the brief: remove cancelled and diverted flights and rows with no arrival delay, then duplicates and impossible values, which leaves 6,879,483 flights. The bigger issue is leakage. Columns such as wheels-on time or the delay-cause minutes are only known after landing, so they are never loaded. I also excluded departure delay and taxi-out time. There's a subtle trap too: if you count flights per hour after removing cancellations, a stormy day looks quiet, and the feature leaks the outcome. So those counts are calculated on the full schedule first.</a:t>
             </a:r>
           </a:p>
         </p:txBody>
@@ -1787,7 +1787,7 @@
           <a:lstStyle/>
           <a:p>
             <a:r>
-              <a:t>[6:02-6:33]  This is the target-encoding code. The encoders are fitted on the training split only, so the validation and test flights never influence them. The output shows why one-hot encoding was not an option: there are 6,886 routes and 4,499 airport-and-hour combinations. The second cell is the leakage guard: an assertion compares the feature list with the forbidden columns, and the run stops if any of them is there. In my run it passed.</a:t>
+              <a:t>[6:02-6:34]  This is the target-encoding code. The encoders are fitted on the training split only, so the validation and test flights never influence them. The output shows why one-hot encoding was not an option: there are 6,886 routes and 4,499 airport-and-hour combinations. The second cell is the leakage guard: an assertion compares the feature list with the forbidden columns, and the run stops if any of them is there. In my run it passed.</a:t>
             </a:r>
           </a:p>
         </p:txBody>
@@ -1857,7 +1857,7 @@
           <a:lstStyle/>
           <a:p>
             <a:r>
-              <a:t>[6:33-7:12]  Here is the training pipeline. The data is split 70, 10 and 20 percent into train, validation and test sets. Because Colab only has two cores, models were trained on a 30% sample of the training set, but validation and test were always scored in full. Every model gets class weights, so delayed flights count as much as on-time ones. Each model is tuned with three-fold cross-validation on PR-AUC, the decision threshold is chosen on the validation set, and the test set is used once, at the end.</a:t>
+              <a:t>[6:34-7:12]  Here is the training pipeline. The data is split 70, 10 and 20 percent into train, validation and test sets. Because Colab only has two cores, models were trained on a 30% sample of the training set, but validation and test were always scored in full. Every model gets class weights, so delayed flights count as much as on-time ones. Each model is tuned with three-fold cross-validation on PR-AUC, the decision threshold is chosen on the validation set, and the test set is used once, at the end.</a:t>
             </a:r>
           </a:p>
         </p:txBody>
@@ -1927,7 +1927,7 @@
           <a:lstStyle/>
           <a:p>
             <a:r>
-              <a:t>[7:12-7:45]  And this is the tuning step in Spark MLlib. Each model has a small parameter grid, and CrossValidator runs three-fold cross-validation scored on PR-AUC. The boxed lines are the winners: Random Forest with depth 12 and 120 trees, and boosting with depth 6 and a step size of 0.1, which had the best cross-validated PR-AUC, 0.469. Tuning Random Forest alone took about 37 minutes on Colab, which shows how expensive a grid search is on two cores.</a:t>
+              <a:t>[7:12-7:46]  And this is the tuning step in Spark MLlib. Each model has a small parameter grid, and CrossValidator runs three-fold cross-validation scored on PR-AUC. The boxed lines are the winners: Random Forest with depth 12 and 120 trees, and boosting with depth 6 and a step size of 0.1, which had the best cross-validated PR-AUC, 0.469. Tuning Random Forest alone took about 37 minutes on Colab, which shows how expensive a grid search is on two cores.</a:t>
             </a:r>
           </a:p>
         </p:txBody>
@@ -1997,7 +1997,7 @@
           <a:lstStyle/>
           <a:p>
             <a:r>
-              <a:t>[7:45-8:25]  These are the results on the random test split. Gradient-Boosted Trees came out best, with an F1 of 0.479 and a ROC-AUC of 0.735. In plain terms, it catches about 60 percent of delayed flights, but about six in ten of its delay alerts are false alarms. Notice the last row: a 'model' that always says on time gets 77.70% accuracy and catches zero delays, which is why accuracy alone is misleading here. Both tree models achieved a higher ROC-AUC than Logistic Regression, which suggests that interactions between the features help.</a:t>
+              <a:t>[7:46-8:25]  These are the results on the random test split. Gradient-Boosted Trees came out best, with an F1 of 0.479 and a ROC-AUC of 0.735. In plain terms, it catches about 60 percent of delayed flights, but about six in ten of its delay alerts are false alarms. Notice the last row: a 'model' that always says on time gets 77.70% accuracy and catches zero delays, which is why accuracy alone is misleading here. Both tree models achieved a higher ROC-AUC than Logistic Regression, which suggests that interactions between the features help.</a:t>
             </a:r>
           </a:p>
         </p:txBody>
@@ -2207,7 +2207,7 @@
           <a:lstStyle/>
           <a:p>
             <a:r>
-              <a:t>[9:50-10:01]  Next, I would add weather forecasts, use out-of-fold target encoding inside cross-validation, measure the effect of class weights, and repeat the training on a real cluster.</a:t>
+              <a:t>[9:50-10:02]  Next, I would add weather forecasts, use out-of-fold target encoding inside cross-validation, measure the effect of class weights, and repeat the training on a real cluster.</a:t>
             </a:r>
           </a:p>
         </p:txBody>
@@ -2277,7 +2277,7 @@
           <a:lstStyle/>
           <a:p>
             <a:r>
-              <a:t>[0:24-0:58]  Delays matter because they are expensive: a major U.S. study estimated around 33 billion dollars in 2007 alone. The industry uses a simple rule: a flight that arrives 15 minutes or more after schedule counts as delayed. The Bureau of Transportation Statistics publishes a record for every domestic flight, which gives us millions of labelled examples. If risky flights can be flagged early, airlines can re-plan crews and spare aircraft, and passengers with tight connections can be warned.</a:t>
+              <a:t>[0:25-0:59]  Delays matter because they are expensive: a major U.S. study estimated around 33 billion dollars in 2007 alone. The industry uses a simple rule: a flight that arrives 15 minutes or more after schedule counts as delayed. The Bureau of Transportation Statistics publishes a record for every domestic flight, which gives us millions of labelled examples. If risky flights can be flagged early, airlines can re-plan crews and spare aircraft, and passengers with tight connections can be warned.</a:t>
             </a:r>
           </a:p>
         </p:txBody>
@@ -2347,7 +2347,7 @@
           <a:lstStyle/>
           <a:p>
             <a:r>
-              <a:t>[10:01-10:32]  So what did I learn? First, accuracy can be misleading on imbalanced data. Second, leakage is subtle: removing post-flight columns was easy, but problems like counting flights after cancellations, or encoding categories before cross-validation, only showed up on closer inspection. Third, evaluating on future months changed my view of which model is best. And finally, the engineering side, checkpointing, version differences and memory, took as much effort as the modelling.</a:t>
+              <a:t>[10:02-10:32]  So what did I learn? First, accuracy can be misleading on imbalanced data. Second, leakage is subtle: removing post-flight columns was easy, but problems like counting flights after cancellations, or encoding categories before cross-validation, only showed up on closer inspection. Third, evaluating on future months changed my view of which model is best. And finally, the engineering side, checkpointing, version differences and memory, took as much effort as the modelling.</a:t>
             </a:r>
           </a:p>
         </p:txBody>
@@ -2417,7 +2417,7 @@
           <a:lstStyle/>
           <a:p>
             <a:r>
-              <a:t>[10:32-10:59]  To conclude: I built a Spark pipeline over every U.S. domestic flight in 2025 that excludes post-flight information. On the random split, Gradient-Boosted Trees performed best; on later months, Random Forest had the higher F1. Schedule-only prediction works, but it has a ceiling, and before extending it I would first validate the method itself: the rotation features, the encoding and the chronological validation.</a:t>
+              <a:t>[10:32-11:00]  To conclude: I built a Spark pipeline over every U.S. domestic flight in 2025 that excludes post-flight information. On the random split, Gradient-Boosted Trees performed best; on later months, Random Forest had the higher F1. Schedule-only prediction works, but it has a ceiling, and before extending it I would first validate the method itself: the rotation features, the encoding and the chronological validation.</a:t>
             </a:r>
           </a:p>
         </p:txBody>
@@ -2487,7 +2487,7 @@
           <a:lstStyle/>
           <a:p>
             <a:r>
-              <a:t>[10:59-11:03]  The main references I used are listed here.</a:t>
+              <a:t>[11:00-11:03]  The main references I used are listed here.</a:t>
             </a:r>
           </a:p>
         </p:txBody>
@@ -2627,7 +2627,7 @@
           <a:lstStyle/>
           <a:p>
             <a:r>
-              <a:t>[0:58-1:36]  So the problem statement is: using only information known before departure, will this flight arrive 15 or more minutes late? That makes it a binary classification problem. The 'before departure' condition is the important part. Many online examples use the departure delay as an input, but you only know that once the plane has left, so the model looks accurate but is useless in practice. My approach is to process the whole year with Spark, build features from the schedule only, and compare three Spark MLlib classifiers fairly.</a:t>
+              <a:t>[0:59-1:37]  So the problem statement is: using only information known before departure, will this flight arrive 15 or more minutes late? That makes it a binary classification problem. The 'before departure' condition is the important part. Many online examples use the departure delay as an input, but you only know that once the plane has left, so the model looks accurate but is useless in practice. My approach is to process the whole year with Spark, build features from the schedule only, and compare three Spark MLlib classifiers fairly.</a:t>
             </a:r>
           </a:p>
         </p:txBody>
@@ -2697,7 +2697,7 @@
           <a:lstStyle/>
           <a:p>
             <a:r>
-              <a:t>[1:36-2:05]  I set five objectives: ingest and clean all twelve monthly files in Spark; engineer features with no target leakage; train Logistic Regression, Random Forest and Gradient-Boosted Trees; evaluate them with metrics that suit an imbalanced problem, plus training time; and show how the pipeline scales out. The scope is all 2025 U.S. domestic flights, using schedule information only, running on a free Google Colab machine.</a:t>
+              <a:t>[1:37-2:05]  I set five objectives: ingest and clean all twelve monthly files in Spark; engineer features with no target leakage; train Logistic Regression, Random Forest and Gradient-Boosted Trees; evaluate them with metrics that suit an imbalanced problem, plus training time; and show how the pipeline scales out. The scope is all 2025 U.S. domestic flights, using schedule information only, running on a free Google Colab machine.</a:t>
             </a:r>
           </a:p>
         </p:txBody>
@@ -2767,7 +2767,7 @@
           <a:lstStyle/>
           <a:p>
             <a:r>
-              <a:t>[2:05-2:20]  I followed CRISP-DM, the standard process model for data-science projects. It is a cycle rather than a straight line, which matched reality: a trial run, a fix, the full run, and a resume after Colab disconnected.</a:t>
+              <a:t>[2:05-2:21]  I followed CRISP-DM, the standard process model for data-science projects. It is a cycle rather than a straight line, which matched reality: a trial run, a fix, the full run, and a resume after Colab disconnected.</a:t>
             </a:r>
           </a:p>
         </p:txBody>
@@ -2837,7 +2837,7 @@
           <a:lstStyle/>
           <a:p>
             <a:r>
-              <a:t>[2:20-2:55]  The data is the official BTS on-time performance table: twelve monthly CSV files, 3.17 gigabytes, and 7,001,619 flights. Each file has about 110 columns, but I only load 17 of them, for leakage reasons I'll come back to. After cleaning, 22.31% of flights are delayed. So the classes are imbalanced: a model that always says 'on time' would already score 77.70% accuracy. One early optimisation was converting the CSVs to Parquet once; after that, the same query ran 25.1x faster.</a:t>
+              <a:t>[2:21-2:56]  The data is the official BTS on-time performance table: twelve monthly CSV files, 3.17 gigabytes, and 7,001,619 flights. Each file has about 110 columns, but I only load 17 of them, for leakage reasons I'll come back to. After cleaning, 22.31% of flights are delayed. So the classes are imbalanced: a model that always says 'on time' would already score 77.70% accuracy. One early optimisation was converting the CSVs to Parquet once; after that, the same query ran 25.1x faster.</a:t>
             </a:r>
           </a:p>
         </p:txBody>
@@ -2907,7 +2907,7 @@
           <a:lstStyle/>
           <a:p>
             <a:r>
-              <a:t>[2:55-3:23]  Here is what that step looks like in the notebook. The first cell checks that all twelve files are in Drive, 3.17 gigabytes in total. After the union there are 7,001,619 flights. The bottom box is the benchmark: the same aggregation took about 80 seconds on the CSV files and about 3 seconds on Parquet, a 25.1x speed-up, so everything after this reads from Parquet.</a:t>
+              <a:t>[2:56-3:24]  Here is what that step looks like in the notebook. The first cell checks that all twelve files are in Drive, 3.17 gigabytes in total. After the union there are 7,001,619 flights. The bottom box is the benchmark: the same aggregation took about 80 seconds on the CSV files and about 3 seconds on Parquet, a 25.1x speed-up, so everything after this reads from Parquet.</a:t>
             </a:r>
           </a:p>
         </p:txBody>
@@ -2977,7 +2977,7 @@
           <a:lstStyle/>
           <a:p>
             <a:r>
-              <a:t>[3:23-4:00]  Exploring the data showed two patterns that shaped my features. On the left, the delay rate by scheduled departure hour: only about 9 percent of 5am departures arrive late, but by 7pm it's around a third. On the right, the later the leg of the day for an aircraft, the more likely it is to be late, and very tight turnarounds under 40 minutes have a 38 percent delay rate. Delays roll forward through an aircraft's day, so I built features that capture exactly that.</a:t>
+              <a:t>[3:24-4:01]  Exploring the data showed two patterns that shaped my features. On the left, the delay rate by scheduled departure hour: only about 9 percent of 5am departures arrive late, but by 7pm it's around a third. On the right, the later the leg of the day for an aircraft, the more likely it is to be late, and very tight turnarounds under 40 minutes have a 38 percent delay rate. Delays roll forward through an aircraft's day, so I built features that capture exactly that.</a:t>
             </a:r>
           </a:p>
         </p:txBody>
@@ -3047,7 +3047,7 @@
           <a:lstStyle/>
           <a:p>
             <a:r>
-              <a:t>[4:00-4:34]  This is the whole pipeline. The twelve files sit in Google Drive. Spark reads each month, maps the column names, keeps only the allowed columns and unions them into one DataFrame. That is written once to Parquet, which also acts as a checkpoint. Then come the schedule features, cleaning and the label. The second row is the machine learning layer: split, encode, train, tune and evaluate, and finally export every chart and table used in my report.</a:t>
+              <a:t>[4:01-4:34]  This is the whole pipeline. The twelve files sit in Google Drive. Spark reads each month, maps the column names, keeps only the allowed columns and unions them into one DataFrame. That is written once to Parquet, which also acts as a checkpoint. Then come the schedule features, cleaning and the label. The second row is the machine learning layer: split, encode, train, tune and evaluate, and finally export every chart and table used in my report.</a:t>
             </a:r>
           </a:p>
         </p:txBody>
@@ -10352,7 +10352,7 @@
           <a:lstStyle/>
           <a:p>
             <a:r>
-              <a:t>Kelvin Soh  ·  Student ID: [Student ID]  ·  M33877  ·  November 2026</a:t>
+              <a:t>Soh Chee Yong  ·  Student ID: UP2653853  ·  M33877  ·  November 2026</a:t>
             </a:r>
           </a:p>
         </p:txBody>

</xml_diff>